<commit_message>
Branding: GAI Observe logo asset + deck with logo on title slide
</commit_message>
<xml_diff>
--- a/business/POC-BUSINESS-CASE-DECK.pptx
+++ b/business/POC-BUSINESS-CASE-DECK.pptx
@@ -3204,6 +3204,30 @@
           </a:p>
         </p:txBody>
       </p:sp>
+      <p:pic>
+        <p:nvPicPr>
+          <p:cNvPr id="5" name="Picture 4" descr="gai-observe-logo.png"/>
+          <p:cNvPicPr>
+            <a:picLocks noChangeAspect="1"/>
+          </p:cNvPicPr>
+          <p:nvPr/>
+        </p:nvPicPr>
+        <p:blipFill>
+          <a:blip r:embed="rId2"/>
+          <a:stretch>
+            <a:fillRect/>
+          </a:stretch>
+        </p:blipFill>
+        <p:spPr>
+          <a:xfrm>
+            <a:off x="5367528" y="320040"/>
+            <a:ext cx="1463040" cy="1463040"/>
+          </a:xfrm>
+          <a:prstGeom prst="rect">
+            <a:avLst/>
+          </a:prstGeom>
+        </p:spPr>
+      </p:pic>
     </p:spTree>
   </p:cSld>
   <p:clrMapOvr>

</xml_diff>

<commit_message>
Sync binaries: unified-style charts for all six notebooks, Day 2 infographic PNGs, rebuilt six-POC business deck
</commit_message>
<xml_diff>
--- a/business/POC-BUSINESS-CASE-DECK.pptx
+++ b/business/POC-BUSINESS-CASE-DECK.pptx
@@ -13,6 +13,8 @@
     <p:sldId id="261" r:id="rId12"/>
     <p:sldId id="262" r:id="rId13"/>
     <p:sldId id="263" r:id="rId14"/>
+    <p:sldId id="264" r:id="rId15"/>
+    <p:sldId id="265" r:id="rId16"/>
   </p:sldIdLst>
   <p:sldSz cx="12191695" cy="6858000" type="screen4x3"/>
   <p:notesSz cx="6858000" cy="9144000"/>
@@ -3097,157 +3099,6 @@
       <p:grpSpPr/>
       <p:sp>
         <p:nvSpPr>
-          <p:cNvPr id="2" name="TextBox 1"/>
-          <p:cNvSpPr txBox="1"/>
-          <p:nvPr/>
-        </p:nvSpPr>
-        <p:spPr>
-          <a:xfrm>
-            <a:off x="640080" y="2011680"/>
-            <a:ext cx="10972800" cy="1463040"/>
-          </a:xfrm>
-          <a:prstGeom prst="rect">
-            <a:avLst/>
-          </a:prstGeom>
-          <a:noFill/>
-        </p:spPr>
-        <p:txBody>
-          <a:bodyPr wrap="square">
-            <a:spAutoFit/>
-          </a:bodyPr>
-          <a:lstStyle/>
-          <a:p>
-            <a:pPr>
-              <a:defRPr sz="4400" b="1">
-                <a:solidFill>
-                  <a:srgbClr val="1A1A2E"/>
-                </a:solidFill>
-              </a:defRPr>
-            </a:pPr>
-            <a:r>
-              <a:t>POC Learning Lab — The Business Case</a:t>
-            </a:r>
-          </a:p>
-        </p:txBody>
-      </p:sp>
-      <p:sp>
-        <p:nvSpPr>
-          <p:cNvPr id="3" name="TextBox 2"/>
-          <p:cNvSpPr txBox="1"/>
-          <p:nvPr/>
-        </p:nvSpPr>
-        <p:spPr>
-          <a:xfrm>
-            <a:off x="640080" y="3291840"/>
-            <a:ext cx="10972800" cy="1280160"/>
-          </a:xfrm>
-          <a:prstGeom prst="rect">
-            <a:avLst/>
-          </a:prstGeom>
-          <a:noFill/>
-        </p:spPr>
-        <p:txBody>
-          <a:bodyPr wrap="square">
-            <a:spAutoFit/>
-          </a:bodyPr>
-          <a:lstStyle/>
-          <a:p>
-            <a:pPr>
-              <a:defRPr sz="2200">
-                <a:solidFill>
-                  <a:srgbClr val="555555"/>
-                </a:solidFill>
-              </a:defRPr>
-            </a:pPr>
-            <a:r>
-              <a:t>Three agent patterns an executive can inspect before funding anything.</a:t>
-            </a:r>
-            <a:br/>
-            <a:r>
-              <a:t>GAI Observe LLC · Executive brief · October 2026</a:t>
-            </a:r>
-          </a:p>
-        </p:txBody>
-      </p:sp>
-      <p:sp>
-        <p:nvSpPr>
-          <p:cNvPr id="4" name="TextBox 3"/>
-          <p:cNvSpPr txBox="1"/>
-          <p:nvPr/>
-        </p:nvSpPr>
-        <p:spPr>
-          <a:xfrm>
-            <a:off x="640080" y="4937760"/>
-            <a:ext cx="10972800" cy="731520"/>
-          </a:xfrm>
-          <a:prstGeom prst="rect">
-            <a:avLst/>
-          </a:prstGeom>
-          <a:noFill/>
-        </p:spPr>
-        <p:txBody>
-          <a:bodyPr wrap="square">
-            <a:spAutoFit/>
-          </a:bodyPr>
-          <a:lstStyle/>
-          <a:p>
-            <a:pPr>
-              <a:defRPr sz="1500" i="1">
-                <a:solidFill>
-                  <a:srgbClr val="C1666B"/>
-                </a:solidFill>
-              </a:defRPr>
-            </a:pPr>
-            <a:r>
-              <a:t>Honesty note: the Day 1 notebooks are scripted demonstrations over synthetic data, labelled ILLUSTRATIVE in the repository. The measured-pilot standard is slide 7.</a:t>
-            </a:r>
-          </a:p>
-        </p:txBody>
-      </p:sp>
-      <p:pic>
-        <p:nvPicPr>
-          <p:cNvPr id="5" name="Picture 4" descr="gai-observe-logo.png"/>
-          <p:cNvPicPr>
-            <a:picLocks noChangeAspect="1"/>
-          </p:cNvPicPr>
-          <p:nvPr/>
-        </p:nvPicPr>
-        <p:blipFill>
-          <a:blip r:embed="rId2"/>
-          <a:stretch>
-            <a:fillRect/>
-          </a:stretch>
-        </p:blipFill>
-        <p:spPr>
-          <a:xfrm>
-            <a:off x="5367528" y="320040"/>
-            <a:ext cx="1463040" cy="1463040"/>
-          </a:xfrm>
-          <a:prstGeom prst="rect">
-            <a:avLst/>
-          </a:prstGeom>
-        </p:spPr>
-      </p:pic>
-    </p:spTree>
-  </p:cSld>
-  <p:clrMapOvr>
-    <a:masterClrMapping/>
-  </p:clrMapOvr>
-</p:sld>
-</file>
-
-<file path=ppt/slides/slide2.xml><?xml version="1.0" encoding="utf-8"?>
-<p:sld xmlns:a="http://schemas.openxmlformats.org/drawingml/2006/main" xmlns:p="http://schemas.openxmlformats.org/presentationml/2006/main" xmlns:r="http://schemas.openxmlformats.org/officeDocument/2006/relationships">
-  <p:cSld>
-    <p:spTree>
-      <p:nvGrpSpPr>
-        <p:cNvPr id="1" name=""/>
-        <p:cNvGrpSpPr/>
-        <p:nvPr/>
-      </p:nvGrpSpPr>
-      <p:grpSpPr/>
-      <p:sp>
-        <p:nvSpPr>
           <p:cNvPr id="2" name="Rectangle 1"/>
           <p:cNvSpPr/>
           <p:nvPr/>
@@ -3255,13 +3106,13 @@
         <p:spPr>
           <a:xfrm>
             <a:off x="0" y="0"/>
-            <a:ext cx="12191695" cy="109728"/>
+            <a:ext cx="12191695" cy="6858000"/>
           </a:xfrm>
           <a:prstGeom prst="rect">
             <a:avLst/>
           </a:prstGeom>
           <a:solidFill>
-            <a:srgbClr val="1B9AAA"/>
+            <a:srgbClr val="0F2A44"/>
           </a:solidFill>
           <a:ln>
             <a:noFill/>
@@ -3297,8 +3148,8 @@
         </p:nvSpPr>
         <p:spPr>
           <a:xfrm>
-            <a:off x="640080" y="411480"/>
-            <a:ext cx="10972800" cy="1005840"/>
+            <a:off x="822960" y="1371600"/>
+            <a:ext cx="10515600" cy="4206240"/>
           </a:xfrm>
           <a:prstGeom prst="rect">
             <a:avLst/>
@@ -3306,20 +3157,56 @@
           <a:noFill/>
         </p:spPr>
         <p:txBody>
-          <a:bodyPr wrap="square">
+          <a:bodyPr wrap="none">
             <a:spAutoFit/>
           </a:bodyPr>
           <a:lstStyle/>
           <a:p>
-            <a:pPr>
-              <a:defRPr sz="3400" b="1">
-                <a:solidFill>
-                  <a:srgbClr val="1A1A2E"/>
-                </a:solidFill>
-              </a:defRPr>
-            </a:pPr>
-            <a:r>
-              <a:t>Why agents fail in business — it is rarely the model</a:t>
+            <a:pPr algn="l"/>
+            <a:r>
+              <a:rPr sz="1600" b="1">
+                <a:solidFill>
+                  <a:srgbClr val="C9962C"/>
+                </a:solidFill>
+                <a:latin typeface="Calibri"/>
+              </a:rPr>
+              <a:t>▸ GAI OBSERVE LLC · POC LEARNING LAB</a:t>
+            </a:r>
+          </a:p>
+          <a:p>
+            <a:pPr algn="l"/>
+            <a:r>
+              <a:rPr sz="4000" b="1">
+                <a:solidFill>
+                  <a:srgbClr val="FFFFFF"/>
+                </a:solidFill>
+                <a:latin typeface="Calibri"/>
+              </a:rPr>
+              <a:t>Six control patterns for enterprise agentic AI</a:t>
+            </a:r>
+          </a:p>
+          <a:p>
+            <a:pPr algn="l"/>
+            <a:r>
+              <a:rPr sz="2600" b="0">
+                <a:solidFill>
+                  <a:srgbClr val="FFFFFF"/>
+                </a:solidFill>
+                <a:latin typeface="Calibri"/>
+              </a:rPr>
+              <a:t>The Business Case — POCs 01–06</a:t>
+            </a:r>
+          </a:p>
+          <a:p>
+            <a:pPr algn="l"/>
+            <a:r>
+              <a:rPr sz="1500" b="0">
+                <a:solidFill>
+                  <a:srgbClr val="D8DEE6"/>
+                </a:solidFill>
+                <a:latin typeface="Calibri"/>
+              </a:rPr>
+              <a:t>Scripted demonstrations on synthetic data. Every figure in this deck is ILLUSTRATIVE — drawn from runs recorded in the public repository, quoted with that label.</a:t>
             </a:r>
           </a:p>
         </p:txBody>
@@ -3332,8 +3219,8 @@
         </p:nvSpPr>
         <p:spPr>
           <a:xfrm>
-            <a:off x="640080" y="1920240"/>
-            <a:ext cx="10972800" cy="4480560"/>
+            <a:off x="822960" y="5852160"/>
+            <a:ext cx="10515600" cy="548640"/>
           </a:xfrm>
           <a:prstGeom prst="rect">
             <a:avLst/>
@@ -3341,103 +3228,20 @@
           <a:noFill/>
         </p:spPr>
         <p:txBody>
-          <a:bodyPr wrap="square">
-            <a:spAutoFit/>
-          </a:bodyPr>
-          <a:lstStyle/>
-          <a:p>
-            <a:pPr>
-              <a:spcAft>
-                <a:spcPts val="1400"/>
-              </a:spcAft>
-              <a:defRPr sz="2100">
-                <a:solidFill>
-                  <a:srgbClr val="1A1A2E"/>
-                </a:solidFill>
-              </a:defRPr>
-            </a:pPr>
-            <a:r>
-              <a:t>• Claims nobody can trace — a vision agent asserts; nobody can check where it looked.</a:t>
-            </a:r>
-          </a:p>
-          <a:p>
-            <a:pPr>
-              <a:spcAft>
-                <a:spcPts val="1400"/>
-              </a:spcAft>
-              <a:defRPr sz="2100">
-                <a:solidFill>
-                  <a:srgbClr val="1A1A2E"/>
-                </a:solidFill>
-              </a:defRPr>
-            </a:pPr>
-            <a:r>
-              <a:t>• State nobody can audit — work happens in side channels; the audit is a reconstruction.</a:t>
-            </a:r>
-          </a:p>
-          <a:p>
-            <a:pPr>
-              <a:spcAft>
-                <a:spcPts val="1400"/>
-              </a:spcAft>
-              <a:defRPr sz="2100">
-                <a:solidFill>
-                  <a:srgbClr val="1A1A2E"/>
-                </a:solidFill>
-              </a:defRPr>
-            </a:pPr>
-            <a:r>
-              <a:t>• Behaviour nobody contracted — scope invented at runtime, outputs downstream cannot consume, runs that never cleanly end.</a:t>
-            </a:r>
-          </a:p>
-          <a:p>
-            <a:pPr>
-              <a:spcAft>
-                <a:spcPts val="1400"/>
-              </a:spcAft>
-              <a:defRPr sz="2100">
-                <a:solidFill>
-                  <a:srgbClr val="1A1A2E"/>
-                </a:solidFill>
-              </a:defRPr>
-            </a:pPr>
-            <a:r>
-              <a:t>The lab's three patterns are the cheapest known controls for exactly these three failures — each one small, runnable, and public.</a:t>
-            </a:r>
-          </a:p>
-        </p:txBody>
-      </p:sp>
-      <p:sp>
-        <p:nvSpPr>
-          <p:cNvPr id="5" name="TextBox 4"/>
-          <p:cNvSpPr txBox="1"/>
-          <p:nvPr/>
-        </p:nvSpPr>
-        <p:spPr>
-          <a:xfrm>
-            <a:off x="640080" y="6419088"/>
-            <a:ext cx="10972800" cy="320040"/>
-          </a:xfrm>
-          <a:prstGeom prst="rect">
-            <a:avLst/>
-          </a:prstGeom>
-          <a:noFill/>
-        </p:spPr>
-        <p:txBody>
           <a:bodyPr wrap="none">
             <a:spAutoFit/>
           </a:bodyPr>
           <a:lstStyle/>
           <a:p>
-            <a:pPr>
-              <a:defRPr sz="1100">
-                <a:solidFill>
-                  <a:srgbClr val="555555"/>
-                </a:solidFill>
-              </a:defRPr>
-            </a:pPr>
-            <a:r>
-              <a:t>GAI Observe LLC · POC Learning Lab · github.com/GAI-Engineering/poc-learning-lab</a:t>
+            <a:pPr algn="l"/>
+            <a:r>
+              <a:rPr sz="1300" b="0">
+                <a:solidFill>
+                  <a:srgbClr val="B9C4D4"/>
+                </a:solidFill>
+                <a:latin typeface="Calibri"/>
+              </a:rPr>
+              <a:t>GAI-Engineering/poc-learning-lab · MIT (code) · CC BY 4.0 (content) · October 2026</a:t>
             </a:r>
           </a:p>
         </p:txBody>
@@ -3450,7 +3254,7 @@
 </p:sld>
 </file>
 
-<file path=ppt/slides/slide3.xml><?xml version="1.0" encoding="utf-8"?>
+<file path=ppt/slides/slide10.xml><?xml version="1.0" encoding="utf-8"?>
 <p:sld xmlns:a="http://schemas.openxmlformats.org/drawingml/2006/main" xmlns:p="http://schemas.openxmlformats.org/presentationml/2006/main" xmlns:r="http://schemas.openxmlformats.org/officeDocument/2006/relationships">
   <p:cSld>
     <p:spTree>
@@ -3469,13 +3273,13 @@
         <p:spPr>
           <a:xfrm>
             <a:off x="0" y="0"/>
-            <a:ext cx="12191695" cy="109728"/>
+            <a:ext cx="12191695" cy="566928"/>
           </a:xfrm>
           <a:prstGeom prst="rect">
             <a:avLst/>
           </a:prstGeom>
           <a:solidFill>
-            <a:srgbClr val="1B9AAA"/>
+            <a:srgbClr val="0F2A44"/>
           </a:solidFill>
           <a:ln>
             <a:noFill/>
@@ -3496,10 +3300,19 @@
           </a:fontRef>
         </p:style>
         <p:txBody>
-          <a:bodyPr rtlCol="0" anchor="ctr"/>
-          <a:lstStyle/>
-          <a:p>
-            <a:pPr algn="ctr"/>
+          <a:bodyPr rtlCol="0" anchor="ctr" wrap="square"/>
+          <a:lstStyle/>
+          <a:p>
+            <a:pPr algn="l"/>
+            <a:r>
+              <a:rPr sz="1500" b="1">
+                <a:solidFill>
+                  <a:srgbClr val="FFFFFF"/>
+                </a:solidFill>
+                <a:latin typeface="Calibri"/>
+              </a:rPr>
+              <a:t>METHOD — HOW THIS LAB EARNS TRUST</a:t>
+            </a:r>
           </a:p>
         </p:txBody>
       </p:sp>
@@ -3511,8 +3324,8 @@
         </p:nvSpPr>
         <p:spPr>
           <a:xfrm>
-            <a:off x="640080" y="411480"/>
-            <a:ext cx="10972800" cy="1005840"/>
+            <a:off x="640080" y="1005840"/>
+            <a:ext cx="10972800" cy="5486400"/>
           </a:xfrm>
           <a:prstGeom prst="rect">
             <a:avLst/>
@@ -3520,153 +3333,88 @@
           <a:noFill/>
         </p:spPr>
         <p:txBody>
-          <a:bodyPr wrap="square">
-            <a:spAutoFit/>
-          </a:bodyPr>
-          <a:lstStyle/>
-          <a:p>
-            <a:pPr>
-              <a:defRPr sz="3400" b="1">
-                <a:solidFill>
-                  <a:srgbClr val="1A1A2E"/>
-                </a:solidFill>
-              </a:defRPr>
-            </a:pPr>
-            <a:r>
-              <a:t>Pattern 1 · Grounded perception + verification (POC 01)</a:t>
-            </a:r>
-          </a:p>
-        </p:txBody>
-      </p:sp>
-      <p:sp>
-        <p:nvSpPr>
-          <p:cNvPr id="4" name="TextBox 3"/>
-          <p:cNvSpPr txBox="1"/>
-          <p:nvPr/>
-        </p:nvSpPr>
-        <p:spPr>
-          <a:xfrm>
-            <a:off x="640080" y="1920240"/>
-            <a:ext cx="10972800" cy="4480560"/>
-          </a:xfrm>
-          <a:prstGeom prst="rect">
-            <a:avLst/>
-          </a:prstGeom>
-          <a:noFill/>
-        </p:spPr>
-        <p:txBody>
-          <a:bodyPr wrap="square">
-            <a:spAutoFit/>
-          </a:bodyPr>
-          <a:lstStyle/>
-          <a:p>
-            <a:pPr>
-              <a:spcAft>
-                <a:spcPts val="1400"/>
-              </a:spcAft>
-              <a:defRPr sz="2100">
-                <a:solidFill>
-                  <a:srgbClr val="1A1A2E"/>
-                </a:solidFill>
-              </a:defRPr>
-            </a:pPr>
-            <a:r>
-              <a:t>Flow: scene → claims (region + confidence) → flag rule → verification → survival rate.</a:t>
-            </a:r>
-          </a:p>
-          <a:p>
-            <a:pPr>
-              <a:spcAft>
-                <a:spcPts val="1400"/>
-              </a:spcAft>
-              <a:defRPr sz="2100">
-                <a:solidFill>
-                  <a:srgbClr val="1A1A2E"/>
-                </a:solidFill>
-              </a:defRPr>
-            </a:pPr>
-            <a:r>
-              <a:t>The money: unverified automation is rework with a latency period. The survival rate prices human touch BEFORE scale.</a:t>
-            </a:r>
-          </a:p>
-          <a:p>
-            <a:pPr>
-              <a:spcAft>
-                <a:spcPts val="1400"/>
-              </a:spcAft>
-              <a:defRPr sz="2100">
-                <a:solidFill>
-                  <a:srgbClr val="1A1A2E"/>
-                </a:solidFill>
-              </a:defRPr>
-            </a:pPr>
-            <a:r>
-              <a:t>Insurance &amp; field services — photo claims triage, damage assessment.</a:t>
-            </a:r>
-          </a:p>
-          <a:p>
-            <a:pPr>
-              <a:spcAft>
-                <a:spcPts val="1400"/>
-              </a:spcAft>
-              <a:defRPr sz="2100">
-                <a:solidFill>
-                  <a:srgbClr val="1A1A2E"/>
-                </a:solidFill>
-              </a:defRPr>
-            </a:pPr>
-            <a:r>
-              <a:t>Construction &amp; facilities — site-inspection QA.  Retail — shelf/signage audits.</a:t>
-            </a:r>
-          </a:p>
-          <a:p>
-            <a:pPr>
-              <a:spcAft>
-                <a:spcPts val="1400"/>
-              </a:spcAft>
-              <a:defRPr sz="2100">
-                <a:solidFill>
-                  <a:srgbClr val="1A1A2E"/>
-                </a:solidFill>
-              </a:defRPr>
-            </a:pPr>
-            <a:r>
-              <a:t>Public sector — accessibility audits of public spaces (the demo's case).</a:t>
-            </a:r>
-          </a:p>
-        </p:txBody>
-      </p:sp>
-      <p:sp>
-        <p:nvSpPr>
-          <p:cNvPr id="5" name="TextBox 4"/>
-          <p:cNvSpPr txBox="1"/>
-          <p:nvPr/>
-        </p:nvSpPr>
-        <p:spPr>
-          <a:xfrm>
-            <a:off x="640080" y="6419088"/>
-            <a:ext cx="10972800" cy="320040"/>
-          </a:xfrm>
-          <a:prstGeom prst="rect">
-            <a:avLst/>
-          </a:prstGeom>
-          <a:noFill/>
-        </p:spPr>
-        <p:txBody>
           <a:bodyPr wrap="none">
             <a:spAutoFit/>
           </a:bodyPr>
           <a:lstStyle/>
           <a:p>
-            <a:pPr>
-              <a:defRPr sz="1100">
-                <a:solidFill>
-                  <a:srgbClr val="555555"/>
-                </a:solidFill>
-              </a:defRPr>
+            <a:pPr algn="l">
+              <a:spcBef>
+                <a:spcPts val="900"/>
+              </a:spcBef>
             </a:pPr>
             <a:r>
-              <a:t>GAI Observe LLC · POC Learning Lab · github.com/GAI-Engineering/poc-learning-lab</a:t>
+              <a:rPr sz="1550" b="0">
+                <a:solidFill>
+                  <a:srgbClr val="222222"/>
+                </a:solidFill>
+                <a:latin typeface="Calibri"/>
+              </a:rPr>
+              <a:t>•  Every result is computed from data files in the repo — change an input and the result moves; each notebook carries a perturbation test that proves it.</a:t>
+            </a:r>
+          </a:p>
+          <a:p>
+            <a:pPr algn="l">
+              <a:spcBef>
+                <a:spcPts val="900"/>
+              </a:spcBef>
+            </a:pPr>
+            <a:r>
+              <a:rPr sz="1550" b="0">
+                <a:solidFill>
+                  <a:srgbClr val="222222"/>
+                </a:solidFill>
+                <a:latin typeface="Calibri"/>
+              </a:rPr>
+              <a:t>•  Modes are printed on the face of the work: INTERIM notebooks are scripted demonstrations; a FINAL promotion requires a real recorded run, reproducible end to end, and passes the evaluator’s full QA.</a:t>
+            </a:r>
+          </a:p>
+          <a:p>
+            <a:pPr algn="l">
+              <a:spcBef>
+                <a:spcPts val="900"/>
+              </a:spcBef>
+            </a:pPr>
+            <a:r>
+              <a:rPr sz="1550" b="0">
+                <a:solidFill>
+                  <a:srgbClr val="222222"/>
+                </a:solidFill>
+                <a:latin typeface="Calibri"/>
+              </a:rPr>
+              <a:t>•  Releases are signed by an independent evaluator of record, with conditions recorded in RELEASES.md and closed only on evidence.</a:t>
+            </a:r>
+          </a:p>
+          <a:p>
+            <a:pPr algn="l">
+              <a:spcBef>
+                <a:spcPts val="900"/>
+              </a:spcBef>
+            </a:pPr>
+            <a:r>
+              <a:rPr sz="1550" b="0">
+                <a:solidFill>
+                  <a:srgbClr val="222222"/>
+                </a:solidFill>
+                <a:latin typeface="Calibri"/>
+              </a:rPr>
+              <a:t>•  Figures of record are the data-drawn SVG infographics in business/infographics/; generated images are checked figure-by-figure at full size before they are used.</a:t>
+            </a:r>
+          </a:p>
+          <a:p>
+            <a:pPr algn="l">
+              <a:spcBef>
+                <a:spcPts val="900"/>
+              </a:spcBef>
+            </a:pPr>
+            <a:r>
+              <a:rPr sz="1550" b="0">
+                <a:solidFill>
+                  <a:srgbClr val="222222"/>
+                </a:solidFill>
+                <a:latin typeface="Calibri"/>
+              </a:rPr>
+              <a:t>•  Corrections are made in public, in the commit history — including this deck’s predecessors.</a:t>
             </a:r>
           </a:p>
         </p:txBody>
@@ -3679,7 +3427,7 @@
 </p:sld>
 </file>
 
-<file path=ppt/slides/slide4.xml><?xml version="1.0" encoding="utf-8"?>
+<file path=ppt/slides/slide2.xml><?xml version="1.0" encoding="utf-8"?>
 <p:sld xmlns:a="http://schemas.openxmlformats.org/drawingml/2006/main" xmlns:p="http://schemas.openxmlformats.org/presentationml/2006/main" xmlns:r="http://schemas.openxmlformats.org/officeDocument/2006/relationships">
   <p:cSld>
     <p:spTree>
@@ -3698,13 +3446,13 @@
         <p:spPr>
           <a:xfrm>
             <a:off x="0" y="0"/>
-            <a:ext cx="12191695" cy="109728"/>
+            <a:ext cx="12191695" cy="566928"/>
           </a:xfrm>
           <a:prstGeom prst="rect">
             <a:avLst/>
           </a:prstGeom>
           <a:solidFill>
-            <a:srgbClr val="1B9AAA"/>
+            <a:srgbClr val="0F2A44"/>
           </a:solidFill>
           <a:ln>
             <a:noFill/>
@@ -3725,10 +3473,19 @@
           </a:fontRef>
         </p:style>
         <p:txBody>
-          <a:bodyPr rtlCol="0" anchor="ctr"/>
-          <a:lstStyle/>
-          <a:p>
-            <a:pPr algn="ctr"/>
+          <a:bodyPr rtlCol="0" anchor="ctr" wrap="square"/>
+          <a:lstStyle/>
+          <a:p>
+            <a:pPr algn="l"/>
+            <a:r>
+              <a:rPr sz="1500" b="1">
+                <a:solidFill>
+                  <a:srgbClr val="FFFFFF"/>
+                </a:solidFill>
+                <a:latin typeface="Calibri"/>
+              </a:rPr>
+              <a:t>THE MARKET — WHY CONTROL IS THE PRODUCT</a:t>
+            </a:r>
           </a:p>
         </p:txBody>
       </p:sp>
@@ -3740,8 +3497,8 @@
         </p:nvSpPr>
         <p:spPr>
           <a:xfrm>
-            <a:off x="640080" y="411480"/>
-            <a:ext cx="10972800" cy="1005840"/>
+            <a:off x="640080" y="1005840"/>
+            <a:ext cx="10972800" cy="5394960"/>
           </a:xfrm>
           <a:prstGeom prst="rect">
             <a:avLst/>
@@ -3749,153 +3506,128 @@
           <a:noFill/>
         </p:spPr>
         <p:txBody>
-          <a:bodyPr wrap="square">
-            <a:spAutoFit/>
-          </a:bodyPr>
-          <a:lstStyle/>
-          <a:p>
-            <a:pPr>
-              <a:defRPr sz="3400" b="1">
-                <a:solidFill>
-                  <a:srgbClr val="1A1A2E"/>
-                </a:solidFill>
-              </a:defRPr>
-            </a:pPr>
-            <a:r>
-              <a:t>Pattern 2 · The transcript is the system of record (POC 02)</a:t>
-            </a:r>
-          </a:p>
-        </p:txBody>
-      </p:sp>
-      <p:sp>
-        <p:nvSpPr>
-          <p:cNvPr id="4" name="TextBox 3"/>
-          <p:cNvSpPr txBox="1"/>
-          <p:nvPr/>
-        </p:nvSpPr>
-        <p:spPr>
-          <a:xfrm>
-            <a:off x="640080" y="1920240"/>
-            <a:ext cx="10972800" cy="4480560"/>
-          </a:xfrm>
-          <a:prstGeom prst="rect">
-            <a:avLst/>
-          </a:prstGeom>
-          <a:noFill/>
-        </p:spPr>
-        <p:txBody>
-          <a:bodyPr wrap="square">
-            <a:spAutoFit/>
-          </a:bodyPr>
-          <a:lstStyle/>
-          <a:p>
-            <a:pPr>
-              <a:spcAft>
-                <a:spcPts val="1400"/>
-              </a:spcAft>
-              <a:defRPr sz="2100">
-                <a:solidFill>
-                  <a:srgbClr val="1A1A2E"/>
-                </a:solidFill>
-              </a:defRPr>
-            </a:pPr>
-            <a:r>
-              <a:t>Flow: Analyst ↔ transcript ↔ Executor — no side channels; findings and replay read from the transcript alone.</a:t>
-            </a:r>
-          </a:p>
-          <a:p>
-            <a:pPr>
-              <a:spcAft>
-                <a:spcPts val="1400"/>
-              </a:spcAft>
-              <a:defRPr sz="2100">
-                <a:solidFill>
-                  <a:srgbClr val="1A1A2E"/>
-                </a:solidFill>
-              </a:defRPr>
-            </a:pPr>
-            <a:r>
-              <a:t>The money: coordination failures are provenance failures. A transcript-of-record removes reconstruction cost from every audit, dispute and incident review.</a:t>
-            </a:r>
-          </a:p>
-          <a:p>
-            <a:pPr>
-              <a:spcAft>
-                <a:spcPts val="1400"/>
-              </a:spcAft>
-              <a:defRPr sz="2100">
-                <a:solidFill>
-                  <a:srgbClr val="1A1A2E"/>
-                </a:solidFill>
-              </a:defRPr>
-            </a:pPr>
-            <a:r>
-              <a:t>Contact centres — agent-assist wrap-up, QA sampling, complaints.</a:t>
-            </a:r>
-          </a:p>
-          <a:p>
-            <a:pPr>
-              <a:spcAft>
-                <a:spcPts val="1400"/>
-              </a:spcAft>
-              <a:defRPr sz="2100">
-                <a:solidFill>
-                  <a:srgbClr val="1A1A2E"/>
-                </a:solidFill>
-              </a:defRPr>
-            </a:pPr>
-            <a:r>
-              <a:t>Finance operations — reconciliations with a full trail.  Healthcare admin — auditable case coordination.</a:t>
-            </a:r>
-          </a:p>
-          <a:p>
-            <a:pPr>
-              <a:spcAft>
-                <a:spcPts val="1400"/>
-              </a:spcAft>
-              <a:defRPr sz="2100">
-                <a:solidFill>
-                  <a:srgbClr val="1A1A2E"/>
-                </a:solidFill>
-              </a:defRPr>
-            </a:pPr>
-            <a:r>
-              <a:t>Shared services / BPO — any workflow where the client may say: show me.</a:t>
-            </a:r>
-          </a:p>
-        </p:txBody>
-      </p:sp>
-      <p:sp>
-        <p:nvSpPr>
-          <p:cNvPr id="5" name="TextBox 4"/>
-          <p:cNvSpPr txBox="1"/>
-          <p:nvPr/>
-        </p:nvSpPr>
-        <p:spPr>
-          <a:xfrm>
-            <a:off x="640080" y="6419088"/>
-            <a:ext cx="10972800" cy="320040"/>
-          </a:xfrm>
-          <a:prstGeom prst="rect">
-            <a:avLst/>
-          </a:prstGeom>
-          <a:noFill/>
-        </p:spPr>
-        <p:txBody>
           <a:bodyPr wrap="none">
             <a:spAutoFit/>
           </a:bodyPr>
           <a:lstStyle/>
           <a:p>
-            <a:pPr>
-              <a:defRPr sz="1100">
-                <a:solidFill>
-                  <a:srgbClr val="555555"/>
-                </a:solidFill>
-              </a:defRPr>
-            </a:pPr>
-            <a:r>
-              <a:t>GAI Observe LLC · POC Learning Lab · github.com/GAI-Engineering/poc-learning-lab</a:t>
+            <a:pPr algn="l"/>
+            <a:r>
+              <a:rPr sz="2000" b="1">
+                <a:solidFill>
+                  <a:srgbClr val="0E7C7B"/>
+                </a:solidFill>
+                <a:latin typeface="Calibri"/>
+              </a:rPr>
+              <a:t>$2.58B → $24.5B</a:t>
+            </a:r>
+          </a:p>
+          <a:p>
+            <a:pPr algn="l"/>
+            <a:r>
+              <a:rPr sz="1500" b="0">
+                <a:solidFill>
+                  <a:srgbClr val="222222"/>
+                </a:solidFill>
+                <a:latin typeface="Calibri"/>
+              </a:rPr>
+              <a:t>Enterprise agentic AI market, 2024 → 2030 (Grand View Research) — 46.2% CAGR. The spend is arriving whether the controls are ready or not.</a:t>
+            </a:r>
+          </a:p>
+          <a:p>
+            <a:pPr algn="l"/>
+            <a:r>
+              <a:rPr sz="2000" b="1">
+                <a:solidFill>
+                  <a:srgbClr val="0E7C7B"/>
+                </a:solidFill>
+                <a:latin typeface="Calibri"/>
+              </a:rPr>
+              <a:t>40% of enterprise apps</a:t>
+            </a:r>
+          </a:p>
+          <a:p>
+            <a:pPr algn="l"/>
+            <a:r>
+              <a:rPr sz="1500" b="0">
+                <a:solidFill>
+                  <a:srgbClr val="222222"/>
+                </a:solidFill>
+                <a:latin typeface="Calibri"/>
+              </a:rPr>
+              <a:t>will feature task-specific AI agents by the end of 2026 (Gartner, August 2025) — up from less than 5% in 2025.</a:t>
+            </a:r>
+          </a:p>
+          <a:p>
+            <a:pPr algn="l"/>
+            <a:r>
+              <a:rPr sz="2000" b="1">
+                <a:solidFill>
+                  <a:srgbClr val="0E7C7B"/>
+                </a:solidFill>
+                <a:latin typeface="Calibri"/>
+              </a:rPr>
+              <a:t>&gt;40% cancelled</a:t>
+            </a:r>
+          </a:p>
+          <a:p>
+            <a:pPr algn="l"/>
+            <a:r>
+              <a:rPr sz="1500" b="0">
+                <a:solidFill>
+                  <a:srgbClr val="222222"/>
+                </a:solidFill>
+                <a:latin typeface="Calibri"/>
+              </a:rPr>
+              <a:t>of agentic AI projects will be cancelled by the end of 2027 (Gartner, June 2025) — cost, unclear value, inadequate risk controls.</a:t>
+            </a:r>
+          </a:p>
+          <a:p>
+            <a:pPr algn="l"/>
+            <a:r>
+              <a:rPr sz="2000" b="1">
+                <a:solidFill>
+                  <a:srgbClr val="0E7C7B"/>
+                </a:solidFill>
+                <a:latin typeface="Calibri"/>
+              </a:rPr>
+              <a:t>$1.5B → $41.8B</a:t>
+            </a:r>
+          </a:p>
+          <a:p>
+            <a:pPr algn="l"/>
+            <a:r>
+              <a:rPr sz="1500" b="0">
+                <a:solidFill>
+                  <a:srgbClr val="222222"/>
+                </a:solidFill>
+                <a:latin typeface="Calibri"/>
+              </a:rPr>
+              <a:t>Contact-center AI spend, 2025 → 2032 (Omdia) — the buyer this lab designs for.</a:t>
+            </a:r>
+          </a:p>
+          <a:p>
+            <a:pPr algn="l"/>
+            <a:r>
+              <a:rPr sz="2000" b="1">
+                <a:solidFill>
+                  <a:srgbClr val="0E7C7B"/>
+                </a:solidFill>
+                <a:latin typeface="Calibri"/>
+              </a:rPr>
+              <a:t>The gap</a:t>
+            </a:r>
+          </a:p>
+          <a:p>
+            <a:pPr algn="l"/>
+            <a:r>
+              <a:rPr sz="1500" b="0">
+                <a:solidFill>
+                  <a:srgbClr val="222222"/>
+                </a:solidFill>
+                <a:latin typeface="Calibri"/>
+              </a:rPr>
+              <a:t>Growth and cancellation are the same market read twice. The six patterns in this lab are the controls that decide which side of it a deployment lands on.</a:t>
             </a:r>
           </a:p>
         </p:txBody>
@@ -3908,7 +3640,7 @@
 </p:sld>
 </file>
 
-<file path=ppt/slides/slide5.xml><?xml version="1.0" encoding="utf-8"?>
+<file path=ppt/slides/slide3.xml><?xml version="1.0" encoding="utf-8"?>
 <p:sld xmlns:a="http://schemas.openxmlformats.org/drawingml/2006/main" xmlns:p="http://schemas.openxmlformats.org/presentationml/2006/main" xmlns:r="http://schemas.openxmlformats.org/officeDocument/2006/relationships">
   <p:cSld>
     <p:spTree>
@@ -3927,13 +3659,13 @@
         <p:spPr>
           <a:xfrm>
             <a:off x="0" y="0"/>
-            <a:ext cx="12191695" cy="109728"/>
+            <a:ext cx="12191695" cy="566928"/>
           </a:xfrm>
           <a:prstGeom prst="rect">
             <a:avLst/>
           </a:prstGeom>
           <a:solidFill>
-            <a:srgbClr val="1B9AAA"/>
+            <a:srgbClr val="0F2A44"/>
           </a:solidFill>
           <a:ln>
             <a:noFill/>
@@ -3954,10 +3686,19 @@
           </a:fontRef>
         </p:style>
         <p:txBody>
-          <a:bodyPr rtlCol="0" anchor="ctr"/>
-          <a:lstStyle/>
-          <a:p>
-            <a:pPr algn="ctr"/>
+          <a:bodyPr rtlCol="0" anchor="ctr" wrap="square"/>
+          <a:lstStyle/>
+          <a:p>
+            <a:pPr algn="l"/>
+            <a:r>
+              <a:rPr sz="1500" b="1">
+                <a:solidFill>
+                  <a:srgbClr val="FFFFFF"/>
+                </a:solidFill>
+                <a:latin typeface="Calibri"/>
+              </a:rPr>
+              <a:t>PATTERN 1 — GROUNDED PERCEPTION WITH A VERIFICATION LOOP (POC 01)</a:t>
+            </a:r>
           </a:p>
         </p:txBody>
       </p:sp>
@@ -3969,8 +3710,8 @@
         </p:nvSpPr>
         <p:spPr>
           <a:xfrm>
-            <a:off x="640080" y="411480"/>
-            <a:ext cx="10972800" cy="1005840"/>
+            <a:off x="640080" y="960120"/>
+            <a:ext cx="6675120" cy="5394960"/>
           </a:xfrm>
           <a:prstGeom prst="rect">
             <a:avLst/>
@@ -3978,157 +3719,112 @@
           <a:noFill/>
         </p:spPr>
         <p:txBody>
-          <a:bodyPr wrap="square">
+          <a:bodyPr wrap="none">
             <a:spAutoFit/>
           </a:bodyPr>
           <a:lstStyle/>
           <a:p>
-            <a:pPr>
-              <a:defRPr sz="3400" b="1">
-                <a:solidFill>
-                  <a:srgbClr val="1A1A2E"/>
-                </a:solidFill>
-              </a:defRPr>
+            <a:pPr algn="l"/>
+            <a:r>
+              <a:rPr sz="1900" b="1">
+                <a:solidFill>
+                  <a:srgbClr val="0F2A44"/>
+                </a:solidFill>
+                <a:latin typeface="Calibri"/>
+              </a:rPr>
+              <a:t>An agent that checks its own claims before anyone acts on them.</a:t>
+            </a:r>
+          </a:p>
+          <a:p>
+            <a:pPr algn="l">
+              <a:spcBef>
+                <a:spcPts val="700"/>
+              </a:spcBef>
             </a:pPr>
             <a:r>
-              <a:t>Pattern 3 · Contract before capability — RODS (POC 03)</a:t>
-            </a:r>
-          </a:p>
-        </p:txBody>
-      </p:sp>
-      <p:sp>
-        <p:nvSpPr>
-          <p:cNvPr id="4" name="TextBox 3"/>
-          <p:cNvSpPr txBox="1"/>
+              <a:rPr sz="1450" b="0">
+                <a:solidFill>
+                  <a:srgbClr val="222222"/>
+                </a:solidFill>
+                <a:latin typeface="Calibri"/>
+              </a:rPr>
+              <a:t>•  13 region claims · 10 survived verification · survival rate 0.769</a:t>
+            </a:r>
+          </a:p>
+          <a:p>
+            <a:pPr algn="l">
+              <a:spcBef>
+                <a:spcPts val="700"/>
+              </a:spcBef>
+            </a:pPr>
+            <a:r>
+              <a:rPr sz="1450" b="0">
+                <a:solidFill>
+                  <a:srgbClr val="222222"/>
+                </a:solidFill>
+                <a:latin typeface="Calibri"/>
+              </a:rPr>
+              <a:t>•  Flag rule: confidence &lt; 0.60 = GUESS (flagged, not hidden)</a:t>
+            </a:r>
+          </a:p>
+          <a:p>
+            <a:pPr algn="l">
+              <a:spcBef>
+                <a:spcPts val="700"/>
+              </a:spcBef>
+            </a:pPr>
+            <a:r>
+              <a:rPr sz="1450" b="0">
+                <a:solidFill>
+                  <a:srgbClr val="222222"/>
+                </a:solidFill>
+                <a:latin typeface="Calibri"/>
+              </a:rPr>
+              <a:t>•  The 3 failed claims are exactly the 3 flagged (0.42 / 0.35 / 0.48) — in the demo this holds by construction; the lesson is the loop, not the rate</a:t>
+            </a:r>
+          </a:p>
+          <a:p>
+            <a:pPr algn="l">
+              <a:spcBef>
+                <a:spcPts val="700"/>
+              </a:spcBef>
+            </a:pPr>
+            <a:r>
+              <a:rPr sz="1450" b="0">
+                <a:solidFill>
+                  <a:srgbClr val="222222"/>
+                </a:solidFill>
+                <a:latin typeface="Calibri"/>
+              </a:rPr>
+              <a:t>•  Flip one verification outcome and the headline moves to 0.692 — try it live in the notebook (§ "Change one outcome")</a:t>
+            </a:r>
+          </a:p>
+        </p:txBody>
+      </p:sp>
+      <p:pic>
+        <p:nvPicPr>
+          <p:cNvPr id="4" name="Picture 3" descr="infographic-01-sees.png"/>
+          <p:cNvPicPr>
+            <a:picLocks noChangeAspect="1"/>
+          </p:cNvPicPr>
           <p:nvPr/>
-        </p:nvSpPr>
+        </p:nvPicPr>
+        <p:blipFill>
+          <a:blip r:embed="rId2"/>
+          <a:stretch>
+            <a:fillRect/>
+          </a:stretch>
+        </p:blipFill>
         <p:spPr>
           <a:xfrm>
-            <a:off x="640080" y="1920240"/>
-            <a:ext cx="10972800" cy="4480560"/>
+            <a:off x="7635240" y="868680"/>
+            <a:ext cx="4316687" cy="5394960"/>
           </a:xfrm>
           <a:prstGeom prst="rect">
             <a:avLst/>
           </a:prstGeom>
-          <a:noFill/>
         </p:spPr>
-        <p:txBody>
-          <a:bodyPr wrap="square">
-            <a:spAutoFit/>
-          </a:bodyPr>
-          <a:lstStyle/>
-          <a:p>
-            <a:pPr>
-              <a:spcAft>
-                <a:spcPts val="1400"/>
-              </a:spcAft>
-              <a:defRPr sz="2100">
-                <a:solidFill>
-                  <a:srgbClr val="1A1A2E"/>
-                </a:solidFill>
-              </a:defRPr>
-            </a:pPr>
-            <a:r>
-              <a:t>Flow: four-line contract → linter → run → typed completion signal → termination on the signal.</a:t>
-            </a:r>
-          </a:p>
-          <a:p>
-            <a:pPr>
-              <a:spcAft>
-                <a:spcPts val="1400"/>
-              </a:spcAft>
-              <a:defRPr sz="2100">
-                <a:solidFill>
-                  <a:srgbClr val="1A1A2E"/>
-                </a:solidFill>
-              </a:defRPr>
-            </a:pPr>
-            <a:r>
-              <a:t>The money: agent incidents are contract incidents. Four lines and a checker price the risk BEFORE deployment — the cheapest control in this field.</a:t>
-            </a:r>
-          </a:p>
-          <a:p>
-            <a:pPr>
-              <a:spcAft>
-                <a:spcPts val="1400"/>
-              </a:spcAft>
-              <a:defRPr sz="2100">
-                <a:solidFill>
-                  <a:srgbClr val="1A1A2E"/>
-                </a:solidFill>
-              </a:defRPr>
-            </a:pPr>
-            <a:r>
-              <a:t>Telecom &amp; utilities — regulated operations, SLA extraction.</a:t>
-            </a:r>
-          </a:p>
-          <a:p>
-            <a:pPr>
-              <a:spcAft>
-                <a:spcPts val="1400"/>
-              </a:spcAft>
-              <a:defRPr sz="2100">
-                <a:solidFill>
-                  <a:srgbClr val="1A1A2E"/>
-                </a:solidFill>
-              </a:defRPr>
-            </a:pPr>
-            <a:r>
-              <a:t>Banking &amp; insurance — document extraction with explicit do-nots.</a:t>
-            </a:r>
-          </a:p>
-          <a:p>
-            <a:pPr>
-              <a:spcAft>
-                <a:spcPts val="1400"/>
-              </a:spcAft>
-              <a:defRPr sz="2100">
-                <a:solidFill>
-                  <a:srgbClr val="1A1A2E"/>
-                </a:solidFill>
-              </a:defRPr>
-            </a:pPr>
-            <a:r>
-              <a:t>Legal operations — clause and obligation extraction (the demo's case).  Any enterprise — as the intake gate for internal agents.</a:t>
-            </a:r>
-          </a:p>
-        </p:txBody>
-      </p:sp>
-      <p:sp>
-        <p:nvSpPr>
-          <p:cNvPr id="5" name="TextBox 4"/>
-          <p:cNvSpPr txBox="1"/>
-          <p:nvPr/>
-        </p:nvSpPr>
-        <p:spPr>
-          <a:xfrm>
-            <a:off x="640080" y="6419088"/>
-            <a:ext cx="10972800" cy="320040"/>
-          </a:xfrm>
-          <a:prstGeom prst="rect">
-            <a:avLst/>
-          </a:prstGeom>
-          <a:noFill/>
-        </p:spPr>
-        <p:txBody>
-          <a:bodyPr wrap="none">
-            <a:spAutoFit/>
-          </a:bodyPr>
-          <a:lstStyle/>
-          <a:p>
-            <a:pPr>
-              <a:defRPr sz="1100">
-                <a:solidFill>
-                  <a:srgbClr val="555555"/>
-                </a:solidFill>
-              </a:defRPr>
-            </a:pPr>
-            <a:r>
-              <a:t>GAI Observe LLC · POC Learning Lab · github.com/GAI-Engineering/poc-learning-lab</a:t>
-            </a:r>
-          </a:p>
-        </p:txBody>
-      </p:sp>
+      </p:pic>
     </p:spTree>
   </p:cSld>
   <p:clrMapOvr>
@@ -4137,7 +3833,7 @@
 </p:sld>
 </file>
 
-<file path=ppt/slides/slide6.xml><?xml version="1.0" encoding="utf-8"?>
+<file path=ppt/slides/slide4.xml><?xml version="1.0" encoding="utf-8"?>
 <p:sld xmlns:a="http://schemas.openxmlformats.org/drawingml/2006/main" xmlns:p="http://schemas.openxmlformats.org/presentationml/2006/main" xmlns:r="http://schemas.openxmlformats.org/officeDocument/2006/relationships">
   <p:cSld>
     <p:spTree>
@@ -4156,13 +3852,13 @@
         <p:spPr>
           <a:xfrm>
             <a:off x="0" y="0"/>
-            <a:ext cx="12191695" cy="109728"/>
+            <a:ext cx="12191695" cy="566928"/>
           </a:xfrm>
           <a:prstGeom prst="rect">
             <a:avLst/>
           </a:prstGeom>
           <a:solidFill>
-            <a:srgbClr val="1B9AAA"/>
+            <a:srgbClr val="0F2A44"/>
           </a:solidFill>
           <a:ln>
             <a:noFill/>
@@ -4183,10 +3879,19 @@
           </a:fontRef>
         </p:style>
         <p:txBody>
-          <a:bodyPr rtlCol="0" anchor="ctr"/>
-          <a:lstStyle/>
-          <a:p>
-            <a:pPr algn="ctr"/>
+          <a:bodyPr rtlCol="0" anchor="ctr" wrap="square"/>
+          <a:lstStyle/>
+          <a:p>
+            <a:pPr algn="l"/>
+            <a:r>
+              <a:rPr sz="1500" b="1">
+                <a:solidFill>
+                  <a:srgbClr val="FFFFFF"/>
+                </a:solidFill>
+                <a:latin typeface="Calibri"/>
+              </a:rPr>
+              <a:t>PATTERN 2 — THE TRANSCRIPT IS THE SYSTEM OF RECORD (POC 02)</a:t>
+            </a:r>
           </a:p>
         </p:txBody>
       </p:sp>
@@ -4198,8 +3903,8 @@
         </p:nvSpPr>
         <p:spPr>
           <a:xfrm>
-            <a:off x="640080" y="411480"/>
-            <a:ext cx="10972800" cy="1005840"/>
+            <a:off x="640080" y="960120"/>
+            <a:ext cx="6675120" cy="5394960"/>
           </a:xfrm>
           <a:prstGeom prst="rect">
             <a:avLst/>
@@ -4207,142 +3912,96 @@
           <a:noFill/>
         </p:spPr>
         <p:txBody>
-          <a:bodyPr wrap="square">
+          <a:bodyPr wrap="none">
             <a:spAutoFit/>
           </a:bodyPr>
           <a:lstStyle/>
           <a:p>
-            <a:pPr>
-              <a:defRPr sz="3400" b="1">
-                <a:solidFill>
-                  <a:srgbClr val="1A1A2E"/>
-                </a:solidFill>
-              </a:defRPr>
+            <a:pPr algn="l"/>
+            <a:r>
+              <a:rPr sz="1900" b="1">
+                <a:solidFill>
+                  <a:srgbClr val="0F2A44"/>
+                </a:solidFill>
+                <a:latin typeface="Calibri"/>
+              </a:rPr>
+              <a:t>The transcript is the system of record — coordination you can replay.</a:t>
+            </a:r>
+          </a:p>
+          <a:p>
+            <a:pPr algn="l">
+              <a:spcBef>
+                <a:spcPts val="700"/>
+              </a:spcBef>
             </a:pPr>
             <a:r>
-              <a:t>The concepts on one screen</a:t>
-            </a:r>
-          </a:p>
-        </p:txBody>
-      </p:sp>
-      <p:sp>
-        <p:nvSpPr>
-          <p:cNvPr id="4" name="TextBox 3"/>
-          <p:cNvSpPr txBox="1"/>
+              <a:rPr sz="1450" b="0">
+                <a:solidFill>
+                  <a:srgbClr val="222222"/>
+                </a:solidFill>
+                <a:latin typeface="Calibri"/>
+              </a:rPr>
+              <a:t>•  12 transcript messages · 4 tasks · 2 agents · 0 side channels</a:t>
+            </a:r>
+          </a:p>
+          <a:p>
+            <a:pPr algn="l">
+              <a:spcBef>
+                <a:spcPts val="700"/>
+              </a:spcBef>
+            </a:pPr>
+            <a:r>
+              <a:rPr sz="1450" b="0">
+                <a:solidFill>
+                  <a:srgbClr val="222222"/>
+                </a:solidFill>
+                <a:latin typeface="Calibri"/>
+              </a:rPr>
+              <a:t>•  3 unasked-for findings: $78.00 unused gym charge (Feb–Mar) · coffee subscription billed 3x in March vs 2x · second streaming sub started March</a:t>
+            </a:r>
+          </a:p>
+          <a:p>
+            <a:pPr algn="l">
+              <a:spcBef>
+                <a:spcPts val="700"/>
+              </a:spcBef>
+            </a:pPr>
+            <a:r>
+              <a:rPr sz="1450" b="0">
+                <a:solidFill>
+                  <a:srgbClr val="222222"/>
+                </a:solidFill>
+                <a:latin typeface="Calibri"/>
+              </a:rPr>
+              <a:t>•  State = the transcript file; replay and audit read it alone</a:t>
+            </a:r>
+          </a:p>
+        </p:txBody>
+      </p:sp>
+      <p:pic>
+        <p:nvPicPr>
+          <p:cNvPr id="4" name="Picture 3" descr="infographic-02-conversation.png"/>
+          <p:cNvPicPr>
+            <a:picLocks noChangeAspect="1"/>
+          </p:cNvPicPr>
           <p:nvPr/>
-        </p:nvSpPr>
+        </p:nvPicPr>
+        <p:blipFill>
+          <a:blip r:embed="rId2"/>
+          <a:stretch>
+            <a:fillRect/>
+          </a:stretch>
+        </p:blipFill>
         <p:spPr>
           <a:xfrm>
-            <a:off x="640080" y="1920240"/>
-            <a:ext cx="10972800" cy="4480560"/>
+            <a:off x="7635240" y="868680"/>
+            <a:ext cx="4316687" cy="5394960"/>
           </a:xfrm>
           <a:prstGeom prst="rect">
             <a:avLst/>
           </a:prstGeom>
-          <a:noFill/>
         </p:spPr>
-        <p:txBody>
-          <a:bodyPr wrap="square">
-            <a:spAutoFit/>
-          </a:bodyPr>
-          <a:lstStyle/>
-          <a:p>
-            <a:pPr>
-              <a:spcAft>
-                <a:spcPts val="1400"/>
-              </a:spcAft>
-              <a:defRPr sz="2100">
-                <a:solidFill>
-                  <a:srgbClr val="1A1A2E"/>
-                </a:solidFill>
-              </a:defRPr>
-            </a:pPr>
-            <a:r>
-              <a:t>01 SEE:  scene → claims + confidence → flag → verify → SURVIVAL RATE</a:t>
-            </a:r>
-          </a:p>
-          <a:p>
-            <a:pPr>
-              <a:spcAft>
-                <a:spcPts val="1400"/>
-              </a:spcAft>
-              <a:defRPr sz="2100">
-                <a:solidFill>
-                  <a:srgbClr val="1A1A2E"/>
-                </a:solidFill>
-              </a:defRPr>
-            </a:pPr>
-            <a:r>
-              <a:t>02 TALK: Analyst ↔ TRANSCRIPT (the record) ↔ Executor → findings · replay · audit</a:t>
-            </a:r>
-          </a:p>
-          <a:p>
-            <a:pPr>
-              <a:spcAft>
-                <a:spcPts val="1400"/>
-              </a:spcAft>
-              <a:defRPr sz="2100">
-                <a:solidFill>
-                  <a:srgbClr val="1A1A2E"/>
-                </a:solidFill>
-              </a:defRPr>
-            </a:pPr>
-            <a:r>
-              <a:t>03 RODS: contract → LINT → run → typed signal → clean termination</a:t>
-            </a:r>
-          </a:p>
-          <a:p>
-            <a:pPr>
-              <a:spcAft>
-                <a:spcPts val="1400"/>
-              </a:spcAft>
-              <a:defRPr sz="2100">
-                <a:solidFill>
-                  <a:srgbClr val="1A1A2E"/>
-                </a:solidFill>
-              </a:defRPr>
-            </a:pPr>
-            <a:r>
-              <a:t>Full diagrams (Mermaid, rendered on GitHub): diagrams/CONCEPT-DIAGRAMS.md in the repository.</a:t>
-            </a:r>
-          </a:p>
-        </p:txBody>
-      </p:sp>
-      <p:sp>
-        <p:nvSpPr>
-          <p:cNvPr id="5" name="TextBox 4"/>
-          <p:cNvSpPr txBox="1"/>
-          <p:nvPr/>
-        </p:nvSpPr>
-        <p:spPr>
-          <a:xfrm>
-            <a:off x="640080" y="6419088"/>
-            <a:ext cx="10972800" cy="320040"/>
-          </a:xfrm>
-          <a:prstGeom prst="rect">
-            <a:avLst/>
-          </a:prstGeom>
-          <a:noFill/>
-        </p:spPr>
-        <p:txBody>
-          <a:bodyPr wrap="none">
-            <a:spAutoFit/>
-          </a:bodyPr>
-          <a:lstStyle/>
-          <a:p>
-            <a:pPr>
-              <a:defRPr sz="1100">
-                <a:solidFill>
-                  <a:srgbClr val="555555"/>
-                </a:solidFill>
-              </a:defRPr>
-            </a:pPr>
-            <a:r>
-              <a:t>GAI Observe LLC · POC Learning Lab · github.com/GAI-Engineering/poc-learning-lab</a:t>
-            </a:r>
-          </a:p>
-        </p:txBody>
-      </p:sp>
+      </p:pic>
     </p:spTree>
   </p:cSld>
   <p:clrMapOvr>
@@ -4351,7 +4010,7 @@
 </p:sld>
 </file>
 
-<file path=ppt/slides/slide7.xml><?xml version="1.0" encoding="utf-8"?>
+<file path=ppt/slides/slide5.xml><?xml version="1.0" encoding="utf-8"?>
 <p:sld xmlns:a="http://schemas.openxmlformats.org/drawingml/2006/main" xmlns:p="http://schemas.openxmlformats.org/presentationml/2006/main" xmlns:r="http://schemas.openxmlformats.org/officeDocument/2006/relationships">
   <p:cSld>
     <p:spTree>
@@ -4370,13 +4029,13 @@
         <p:spPr>
           <a:xfrm>
             <a:off x="0" y="0"/>
-            <a:ext cx="12191695" cy="109728"/>
+            <a:ext cx="12191695" cy="566928"/>
           </a:xfrm>
           <a:prstGeom prst="rect">
             <a:avLst/>
           </a:prstGeom>
           <a:solidFill>
-            <a:srgbClr val="1B9AAA"/>
+            <a:srgbClr val="0F2A44"/>
           </a:solidFill>
           <a:ln>
             <a:noFill/>
@@ -4397,10 +4056,19 @@
           </a:fontRef>
         </p:style>
         <p:txBody>
-          <a:bodyPr rtlCol="0" anchor="ctr"/>
-          <a:lstStyle/>
-          <a:p>
-            <a:pPr algn="ctr"/>
+          <a:bodyPr rtlCol="0" anchor="ctr" wrap="square"/>
+          <a:lstStyle/>
+          <a:p>
+            <a:pPr algn="l"/>
+            <a:r>
+              <a:rPr sz="1500" b="1">
+                <a:solidFill>
+                  <a:srgbClr val="FFFFFF"/>
+                </a:solidFill>
+                <a:latin typeface="Calibri"/>
+              </a:rPr>
+              <a:t>PATTERN 3 — CONTRACT BEFORE CAPABILITY (POC 03, RODS)</a:t>
+            </a:r>
           </a:p>
         </p:txBody>
       </p:sp>
@@ -4412,8 +4080,8 @@
         </p:nvSpPr>
         <p:spPr>
           <a:xfrm>
-            <a:off x="640080" y="411480"/>
-            <a:ext cx="10972800" cy="1005840"/>
+            <a:off x="640080" y="960120"/>
+            <a:ext cx="6675120" cy="5394960"/>
           </a:xfrm>
           <a:prstGeom prst="rect">
             <a:avLst/>
@@ -4421,142 +4089,96 @@
           <a:noFill/>
         </p:spPr>
         <p:txBody>
-          <a:bodyPr wrap="square">
+          <a:bodyPr wrap="none">
             <a:spAutoFit/>
           </a:bodyPr>
           <a:lstStyle/>
           <a:p>
-            <a:pPr>
-              <a:defRPr sz="3400" b="1">
-                <a:solidFill>
-                  <a:srgbClr val="1A1A2E"/>
-                </a:solidFill>
-              </a:defRPr>
+            <a:pPr algn="l"/>
+            <a:r>
+              <a:rPr sz="1900" b="1">
+                <a:solidFill>
+                  <a:srgbClr val="0F2A44"/>
+                </a:solidFill>
+                <a:latin typeface="Calibri"/>
+              </a:rPr>
+              <a:t>Four lines of contract, linted before the agent ever runs.</a:t>
+            </a:r>
+          </a:p>
+          <a:p>
+            <a:pPr algn="l">
+              <a:spcBef>
+                <a:spcPts val="700"/>
+              </a:spcBef>
             </a:pPr>
             <a:r>
-              <a:t>From demonstration to deployment — four steps</a:t>
-            </a:r>
-          </a:p>
-        </p:txBody>
-      </p:sp>
-      <p:sp>
-        <p:nvSpPr>
-          <p:cNvPr id="4" name="TextBox 3"/>
-          <p:cNvSpPr txBox="1"/>
+              <a:rPr sz="1450" b="0">
+                <a:solidFill>
+                  <a:srgbClr val="222222"/>
+                </a:solidFill>
+                <a:latin typeface="Calibri"/>
+              </a:rPr>
+              <a:t>•  Contract = 4 lines (Role · Output · Do-Nots · Signal)</a:t>
+            </a:r>
+          </a:p>
+          <a:p>
+            <a:pPr algn="l">
+              <a:spcBef>
+                <a:spcPts val="700"/>
+              </a:spcBef>
+            </a:pPr>
+            <a:r>
+              <a:rPr sz="1450" b="0">
+                <a:solidFill>
+                  <a:srgbClr val="222222"/>
+                </a:solidFill>
+                <a:latin typeface="Calibri"/>
+              </a:rPr>
+              <a:t>•  Good contract: lint CLEAN · Bad contract: 3 flags (MISSING Do-Nots, WEAK_SIGNAL, VAGUE_OUTPUT)</a:t>
+            </a:r>
+          </a:p>
+          <a:p>
+            <a:pPr algn="l">
+              <a:spcBef>
+                <a:spcPts val="700"/>
+              </a:spcBef>
+            </a:pPr>
+            <a:r>
+              <a:rPr sz="1450" b="0">
+                <a:solidFill>
+                  <a:srgbClr val="222222"/>
+                </a:solidFill>
+                <a:latin typeface="Calibri"/>
+              </a:rPr>
+              <a:t>•  Extraction: 4 obligations · termination on the typed signal EXTRACTION COMPLETE (check returned SIGNAL, never a prose word)</a:t>
+            </a:r>
+          </a:p>
+        </p:txBody>
+      </p:sp>
+      <p:pic>
+        <p:nvPicPr>
+          <p:cNvPr id="4" name="Picture 3" descr="infographic-03-rods.png"/>
+          <p:cNvPicPr>
+            <a:picLocks noChangeAspect="1"/>
+          </p:cNvPicPr>
           <p:nvPr/>
-        </p:nvSpPr>
+        </p:nvPicPr>
+        <p:blipFill>
+          <a:blip r:embed="rId2"/>
+          <a:stretch>
+            <a:fillRect/>
+          </a:stretch>
+        </p:blipFill>
         <p:spPr>
           <a:xfrm>
-            <a:off x="640080" y="1920240"/>
-            <a:ext cx="10972800" cy="4480560"/>
+            <a:off x="7635240" y="868680"/>
+            <a:ext cx="4316687" cy="5394960"/>
           </a:xfrm>
           <a:prstGeom prst="rect">
             <a:avLst/>
           </a:prstGeom>
-          <a:noFill/>
         </p:spPr>
-        <p:txBody>
-          <a:bodyPr wrap="square">
-            <a:spAutoFit/>
-          </a:bodyPr>
-          <a:lstStyle/>
-          <a:p>
-            <a:pPr>
-              <a:spcAft>
-                <a:spcPts val="1400"/>
-              </a:spcAft>
-              <a:defRPr sz="2100">
-                <a:solidFill>
-                  <a:srgbClr val="1A1A2E"/>
-                </a:solidFill>
-              </a:defRPr>
-            </a:pPr>
-            <a:r>
-              <a:t>1 · Pattern fit (days) — name the owner and the cost line the pattern moves. No pattern, no project.</a:t>
-            </a:r>
-          </a:p>
-          <a:p>
-            <a:pPr>
-              <a:spcAft>
-                <a:spcPts val="1400"/>
-              </a:spcAft>
-              <a:defRPr sz="2100">
-                <a:solidFill>
-                  <a:srgbClr val="1A1A2E"/>
-                </a:solidFill>
-              </a:defRPr>
-            </a:pPr>
-            <a:r>
-              <a:t>2 · Measured pilot (weeks) — one site, one workflow, human checkers; illustrative metrics become measured ones against a recorded baseline.</a:t>
-            </a:r>
-          </a:p>
-          <a:p>
-            <a:pPr>
-              <a:spcAft>
-                <a:spcPts val="1400"/>
-              </a:spcAft>
-              <a:defRPr sz="2100">
-                <a:solidFill>
-                  <a:srgbClr val="1A1A2E"/>
-                </a:solidFill>
-              </a:defRPr>
-            </a:pPr>
-            <a:r>
-              <a:t>3 · Contract &amp; controls (weeks) — RODS contracts on every agent, transcript-of-record on, verification loop staffed.</a:t>
-            </a:r>
-          </a:p>
-          <a:p>
-            <a:pPr>
-              <a:spcAft>
-                <a:spcPts val="1400"/>
-              </a:spcAft>
-              <a:defRPr sz="2100">
-                <a:solidFill>
-                  <a:srgbClr val="1A1A2E"/>
-                </a:solidFill>
-              </a:defRPr>
-            </a:pPr>
-            <a:r>
-              <a:t>4 · Scale decision — expand only on the measured pilot numbers. The same evidence discipline this repo is published under.</a:t>
-            </a:r>
-          </a:p>
-        </p:txBody>
-      </p:sp>
-      <p:sp>
-        <p:nvSpPr>
-          <p:cNvPr id="5" name="TextBox 4"/>
-          <p:cNvSpPr txBox="1"/>
-          <p:nvPr/>
-        </p:nvSpPr>
-        <p:spPr>
-          <a:xfrm>
-            <a:off x="640080" y="6419088"/>
-            <a:ext cx="10972800" cy="320040"/>
-          </a:xfrm>
-          <a:prstGeom prst="rect">
-            <a:avLst/>
-          </a:prstGeom>
-          <a:noFill/>
-        </p:spPr>
-        <p:txBody>
-          <a:bodyPr wrap="none">
-            <a:spAutoFit/>
-          </a:bodyPr>
-          <a:lstStyle/>
-          <a:p>
-            <a:pPr>
-              <a:defRPr sz="1100">
-                <a:solidFill>
-                  <a:srgbClr val="555555"/>
-                </a:solidFill>
-              </a:defRPr>
-            </a:pPr>
-            <a:r>
-              <a:t>GAI Observe LLC · POC Learning Lab · github.com/GAI-Engineering/poc-learning-lab</a:t>
-            </a:r>
-          </a:p>
-        </p:txBody>
-      </p:sp>
+      </p:pic>
     </p:spTree>
   </p:cSld>
   <p:clrMapOvr>
@@ -4565,7 +4187,7 @@
 </p:sld>
 </file>
 
-<file path=ppt/slides/slide8.xml><?xml version="1.0" encoding="utf-8"?>
+<file path=ppt/slides/slide6.xml><?xml version="1.0" encoding="utf-8"?>
 <p:sld xmlns:a="http://schemas.openxmlformats.org/drawingml/2006/main" xmlns:p="http://schemas.openxmlformats.org/presentationml/2006/main" xmlns:r="http://schemas.openxmlformats.org/officeDocument/2006/relationships">
   <p:cSld>
     <p:spTree>
@@ -4584,13 +4206,13 @@
         <p:spPr>
           <a:xfrm>
             <a:off x="0" y="0"/>
-            <a:ext cx="12191695" cy="109728"/>
+            <a:ext cx="12191695" cy="566928"/>
           </a:xfrm>
           <a:prstGeom prst="rect">
             <a:avLst/>
           </a:prstGeom>
           <a:solidFill>
-            <a:srgbClr val="1B9AAA"/>
+            <a:srgbClr val="0F2A44"/>
           </a:solidFill>
           <a:ln>
             <a:noFill/>
@@ -4611,10 +4233,19 @@
           </a:fontRef>
         </p:style>
         <p:txBody>
-          <a:bodyPr rtlCol="0" anchor="ctr"/>
-          <a:lstStyle/>
-          <a:p>
-            <a:pPr algn="ctr"/>
+          <a:bodyPr rtlCol="0" anchor="ctr" wrap="square"/>
+          <a:lstStyle/>
+          <a:p>
+            <a:pPr algn="l"/>
+            <a:r>
+              <a:rPr sz="1500" b="1">
+                <a:solidFill>
+                  <a:srgbClr val="FFFFFF"/>
+                </a:solidFill>
+                <a:latin typeface="Calibri"/>
+              </a:rPr>
+              <a:t>PATTERN 4 — THE ERROR IS THE CURRICULUM (POC 04)</a:t>
+            </a:r>
           </a:p>
         </p:txBody>
       </p:sp>
@@ -4626,8 +4257,8 @@
         </p:nvSpPr>
         <p:spPr>
           <a:xfrm>
-            <a:off x="640080" y="411480"/>
-            <a:ext cx="10972800" cy="1005840"/>
+            <a:off x="640080" y="960120"/>
+            <a:ext cx="6675120" cy="5394960"/>
           </a:xfrm>
           <a:prstGeom prst="rect">
             <a:avLst/>
@@ -4635,34 +4266,208 @@
           <a:noFill/>
         </p:spPr>
         <p:txBody>
-          <a:bodyPr wrap="square">
+          <a:bodyPr wrap="none">
             <a:spAutoFit/>
           </a:bodyPr>
           <a:lstStyle/>
           <a:p>
-            <a:pPr>
-              <a:defRPr sz="3400" b="1">
-                <a:solidFill>
-                  <a:srgbClr val="1A1A2E"/>
-                </a:solidFill>
-              </a:defRPr>
+            <a:pPr algn="l"/>
+            <a:r>
+              <a:rPr sz="1900" b="1">
+                <a:solidFill>
+                  <a:srgbClr val="0F2A44"/>
+                </a:solidFill>
+                <a:latin typeface="Calibri"/>
+              </a:rPr>
+              <a:t>Every outcome is labelled, and the label teaches the next attempt.</a:t>
+            </a:r>
+          </a:p>
+          <a:p>
+            <a:pPr algn="l">
+              <a:spcBef>
+                <a:spcPts val="700"/>
+              </a:spcBef>
             </a:pPr>
             <a:r>
-              <a:t>The lean start</a:t>
-            </a:r>
-          </a:p>
-        </p:txBody>
-      </p:sp>
-      <p:sp>
-        <p:nvSpPr>
-          <p:cNvPr id="4" name="TextBox 3"/>
+              <a:rPr sz="1450" b="0">
+                <a:solidFill>
+                  <a:srgbClr val="222222"/>
+                </a:solidFill>
+                <a:latin typeface="Calibri"/>
+              </a:rPr>
+              <a:t>•  5 attempts · 1 ERROR · 1 EMPTY · 3 SUCCESS — outcomes computed from the run record (runs/attempts.csv), never typed into the summary</a:t>
+            </a:r>
+          </a:p>
+          <a:p>
+            <a:pPr algn="l">
+              <a:spcBef>
+                <a:spcPts val="700"/>
+              </a:spcBef>
+            </a:pPr>
+            <a:r>
+              <a:rPr sz="1450" b="0">
+                <a:solidFill>
+                  <a:srgbClr val="222222"/>
+                </a:solidFill>
+                <a:latin typeface="Calibri"/>
+              </a:rPr>
+              <a:t>•  The error was a wrong key ('amt'); the recovery habit — print the schema first — is attempt 2, and the revised query succeeds</a:t>
+            </a:r>
+          </a:p>
+          <a:p>
+            <a:pPr algn="l">
+              <a:spcBef>
+                <a:spcPts val="700"/>
+              </a:spcBef>
+            </a:pPr>
+            <a:r>
+              <a:rPr sz="1450" b="0">
+                <a:solidFill>
+                  <a:srgbClr val="222222"/>
+                </a:solidFill>
+                <a:latin typeface="Calibri"/>
+              </a:rPr>
+              <a:t>•  EMPTY means the question was wrong (category 'gym' matches no rows); the exact name from the totals ('gym-unused') succeeds</a:t>
+            </a:r>
+          </a:p>
+          <a:p>
+            <a:pPr algn="l">
+              <a:spcBef>
+                <a:spcPts val="700"/>
+              </a:spcBef>
+            </a:pPr>
+            <a:r>
+              <a:rPr sz="1450" b="0">
+                <a:solidFill>
+                  <a:srgbClr val="222222"/>
+                </a:solidFill>
+                <a:latin typeface="Calibri"/>
+              </a:rPr>
+              <a:t>•  Finding: gym-unused totals $78.00 (2 x $39.00, 2026-02 and 2026-03), traced to rows in data/transactions.csv (22 rows)</a:t>
+            </a:r>
+          </a:p>
+          <a:p>
+            <a:pPr algn="l">
+              <a:spcBef>
+                <a:spcPts val="700"/>
+              </a:spcBef>
+            </a:pPr>
+            <a:r>
+              <a:rPr sz="1450" b="0">
+                <a:solidFill>
+                  <a:srgbClr val="222222"/>
+                </a:solidFill>
+                <a:latin typeface="Calibri"/>
+              </a:rPr>
+              <a:t>•  Change a figure in the CSV and the finding moves — the perturbation test moves the gym amounts and watches $78.00 become $98.00 (tests/test_perturbation.py)</a:t>
+            </a:r>
+          </a:p>
+        </p:txBody>
+      </p:sp>
+      <p:pic>
+        <p:nvPicPr>
+          <p:cNvPr id="4" name="Picture 3" descr="infographic-04-analyst-executor.png"/>
+          <p:cNvPicPr>
+            <a:picLocks noChangeAspect="1"/>
+          </p:cNvPicPr>
+          <p:nvPr/>
+        </p:nvPicPr>
+        <p:blipFill>
+          <a:blip r:embed="rId2"/>
+          <a:stretch>
+            <a:fillRect/>
+          </a:stretch>
+        </p:blipFill>
+        <p:spPr>
+          <a:xfrm>
+            <a:off x="7635240" y="868680"/>
+            <a:ext cx="4315968" cy="5394960"/>
+          </a:xfrm>
+          <a:prstGeom prst="rect">
+            <a:avLst/>
+          </a:prstGeom>
+        </p:spPr>
+      </p:pic>
+    </p:spTree>
+  </p:cSld>
+  <p:clrMapOvr>
+    <a:masterClrMapping/>
+  </p:clrMapOvr>
+</p:sld>
+</file>
+
+<file path=ppt/slides/slide7.xml><?xml version="1.0" encoding="utf-8"?>
+<p:sld xmlns:a="http://schemas.openxmlformats.org/drawingml/2006/main" xmlns:p="http://schemas.openxmlformats.org/presentationml/2006/main" xmlns:r="http://schemas.openxmlformats.org/officeDocument/2006/relationships">
+  <p:cSld>
+    <p:spTree>
+      <p:nvGrpSpPr>
+        <p:cNvPr id="1" name=""/>
+        <p:cNvGrpSpPr/>
+        <p:nvPr/>
+      </p:nvGrpSpPr>
+      <p:grpSpPr/>
+      <p:sp>
+        <p:nvSpPr>
+          <p:cNvPr id="2" name="Rectangle 1"/>
+          <p:cNvSpPr/>
+          <p:nvPr/>
+        </p:nvSpPr>
+        <p:spPr>
+          <a:xfrm>
+            <a:off x="0" y="0"/>
+            <a:ext cx="12191695" cy="566928"/>
+          </a:xfrm>
+          <a:prstGeom prst="rect">
+            <a:avLst/>
+          </a:prstGeom>
+          <a:solidFill>
+            <a:srgbClr val="0F2A44"/>
+          </a:solidFill>
+          <a:ln>
+            <a:noFill/>
+          </a:ln>
+        </p:spPr>
+        <p:style>
+          <a:lnRef idx="1">
+            <a:schemeClr val="accent1"/>
+          </a:lnRef>
+          <a:fillRef idx="3">
+            <a:schemeClr val="accent1"/>
+          </a:fillRef>
+          <a:effectRef idx="2">
+            <a:schemeClr val="accent1"/>
+          </a:effectRef>
+          <a:fontRef idx="minor">
+            <a:schemeClr val="lt1"/>
+          </a:fontRef>
+        </p:style>
+        <p:txBody>
+          <a:bodyPr rtlCol="0" anchor="ctr" wrap="square"/>
+          <a:lstStyle/>
+          <a:p>
+            <a:pPr algn="l"/>
+            <a:r>
+              <a:rPr sz="1500" b="1">
+                <a:solidFill>
+                  <a:srgbClr val="FFFFFF"/>
+                </a:solidFill>
+                <a:latin typeface="Calibri"/>
+              </a:rPr>
+              <a:t>PATTERN 5 — CHOOSE YOUR PARLIAMENT (POC 05)</a:t>
+            </a:r>
+          </a:p>
+        </p:txBody>
+      </p:sp>
+      <p:sp>
+        <p:nvSpPr>
+          <p:cNvPr id="3" name="TextBox 2"/>
           <p:cNvSpPr txBox="1"/>
           <p:nvPr/>
         </p:nvSpPr>
         <p:spPr>
           <a:xfrm>
-            <a:off x="640080" y="1920240"/>
-            <a:ext cx="10972800" cy="4480560"/>
+            <a:off x="640080" y="960120"/>
+            <a:ext cx="6675120" cy="5394960"/>
           </a:xfrm>
           <a:prstGeom prst="rect">
             <a:avLst/>
@@ -4670,82 +4475,192 @@
           <a:noFill/>
         </p:spPr>
         <p:txBody>
-          <a:bodyPr wrap="square">
+          <a:bodyPr wrap="none">
             <a:spAutoFit/>
           </a:bodyPr>
           <a:lstStyle/>
           <a:p>
-            <a:pPr>
-              <a:spcAft>
-                <a:spcPts val="1400"/>
-              </a:spcAft>
-              <a:defRPr sz="2100">
-                <a:solidFill>
-                  <a:srgbClr val="1A1A2E"/>
-                </a:solidFill>
-              </a:defRPr>
+            <a:pPr algn="l"/>
+            <a:r>
+              <a:rPr sz="1900" b="1">
+                <a:solidFill>
+                  <a:srgbClr val="0F2A44"/>
+                </a:solidFill>
+                <a:latin typeface="Calibri"/>
+              </a:rPr>
+              <a:t>Who speaks next is a design decision — count what each shape costs in calls.</a:t>
+            </a:r>
+          </a:p>
+          <a:p>
+            <a:pPr algn="l">
+              <a:spcBef>
+                <a:spcPts val="700"/>
+              </a:spcBef>
             </a:pPr>
             <a:r>
-              <a:t>The reference implementations are free (MIT code / CC BY 4.0 text) and run offline — inspect them before any meeting.</a:t>
-            </a:r>
-          </a:p>
-          <a:p>
-            <a:pPr>
-              <a:spcAft>
-                <a:spcPts val="1400"/>
-              </a:spcAft>
-              <a:defRPr sz="2100">
-                <a:solidFill>
-                  <a:srgbClr val="1A1A2E"/>
-                </a:solidFill>
-              </a:defRPr>
+              <a:rPr sz="1450" b="0">
+                <a:solidFill>
+                  <a:srgbClr val="222222"/>
+                </a:solidFill>
+                <a:latin typeface="Calibri"/>
+              </a:rPr>
+              <a:t>•  Same job, three shapes, counted from runs/routing-comparison.csv: round robin 6 agent turns / 6 total calls · selector 3 agent turns + 4 routing calls / 7 total · swarm 4 agent turns + 3 hand-offs / 4 total</a:t>
+            </a:r>
+          </a:p>
+          <a:p>
+            <a:pPr algn="l">
+              <a:spcBef>
+                <a:spcPts val="700"/>
+              </a:spcBef>
             </a:pPr>
             <a:r>
-              <a:t>Step 2's real cost is people-time: one business owner, one engineer, checker hours for the verification loop.</a:t>
-            </a:r>
-          </a:p>
-          <a:p>
-            <a:pPr>
-              <a:spcAft>
-                <a:spcPts val="1400"/>
-              </a:spcAft>
-              <a:defRPr sz="2100">
-                <a:solidFill>
-                  <a:srgbClr val="1A1A2E"/>
-                </a:solidFill>
-              </a:defRPr>
+              <a:rPr sz="1450" b="0">
+                <a:solidFill>
+                  <a:srgbClr val="222222"/>
+                </a:solidFill>
+                <a:latin typeface="Calibri"/>
+              </a:rPr>
+              <a:t>•  All three modes prepared the same pack (specialty orthopaedics, 2 slots — Tue 09:30, Wed 14:10 — unbooked, awaiting human confirmation)</a:t>
+            </a:r>
+          </a:p>
+          <a:p>
+            <a:pPr algn="l">
+              <a:spcBef>
+                <a:spcPts val="700"/>
+              </a:spcBef>
             </a:pPr>
             <a:r>
-              <a:t>Evidence first. Platform spend after the numbers exist.</a:t>
-            </a:r>
-          </a:p>
-          <a:p>
-            <a:pPr>
-              <a:spcAft>
-                <a:spcPts val="1400"/>
-              </a:spcAft>
-              <a:defRPr sz="2100">
-                <a:solidFill>
-                  <a:srgbClr val="1A1A2E"/>
-                </a:solidFill>
-              </a:defRPr>
+              <a:rPr sz="1450" b="0">
+                <a:solidFill>
+                  <a:srgbClr val="222222"/>
+                </a:solidFill>
+                <a:latin typeface="Calibri"/>
+              </a:rPr>
+              <a:t>•  These counts are the mechanics of this script — round robin runs its sequence twice by construction; the swarm takes a verification hand-back by construction. They are not live routing costs.</a:t>
+            </a:r>
+          </a:p>
+          <a:p>
+            <a:pPr algn="l">
+              <a:spcBef>
+                <a:spcPts val="700"/>
+              </a:spcBef>
             </a:pPr>
             <a:r>
-              <a:t>Repository: github.com/GAI-Engineering/poc-learning-lab — business case: business/BUSINESS-CASE.md</a:t>
-            </a:r>
-          </a:p>
-        </p:txBody>
-      </p:sp>
-      <p:sp>
-        <p:nvSpPr>
-          <p:cNvPr id="5" name="TextBox 4"/>
+              <a:rPr sz="1450" b="0">
+                <a:solidFill>
+                  <a:srgbClr val="222222"/>
+                </a:solidFill>
+                <a:latin typeface="Calibri"/>
+              </a:rPr>
+              <a:t>•  A router that can never finish is capped and ends INCOMPLETE (tests/test_perturbation.py, failed-router case)</a:t>
+            </a:r>
+          </a:p>
+        </p:txBody>
+      </p:sp>
+      <p:pic>
+        <p:nvPicPr>
+          <p:cNvPr id="4" name="Picture 3" descr="infographic-05-group-chat.png"/>
+          <p:cNvPicPr>
+            <a:picLocks noChangeAspect="1"/>
+          </p:cNvPicPr>
+          <p:nvPr/>
+        </p:nvPicPr>
+        <p:blipFill>
+          <a:blip r:embed="rId2"/>
+          <a:stretch>
+            <a:fillRect/>
+          </a:stretch>
+        </p:blipFill>
+        <p:spPr>
+          <a:xfrm>
+            <a:off x="7635240" y="868680"/>
+            <a:ext cx="4315968" cy="5394960"/>
+          </a:xfrm>
+          <a:prstGeom prst="rect">
+            <a:avLst/>
+          </a:prstGeom>
+        </p:spPr>
+      </p:pic>
+    </p:spTree>
+  </p:cSld>
+  <p:clrMapOvr>
+    <a:masterClrMapping/>
+  </p:clrMapOvr>
+</p:sld>
+</file>
+
+<file path=ppt/slides/slide8.xml><?xml version="1.0" encoding="utf-8"?>
+<p:sld xmlns:a="http://schemas.openxmlformats.org/drawingml/2006/main" xmlns:p="http://schemas.openxmlformats.org/presentationml/2006/main" xmlns:r="http://schemas.openxmlformats.org/officeDocument/2006/relationships">
+  <p:cSld>
+    <p:spTree>
+      <p:nvGrpSpPr>
+        <p:cNvPr id="1" name=""/>
+        <p:cNvGrpSpPr/>
+        <p:nvPr/>
+      </p:nvGrpSpPr>
+      <p:grpSpPr/>
+      <p:sp>
+        <p:nvSpPr>
+          <p:cNvPr id="2" name="Rectangle 1"/>
+          <p:cNvSpPr/>
+          <p:nvPr/>
+        </p:nvSpPr>
+        <p:spPr>
+          <a:xfrm>
+            <a:off x="0" y="0"/>
+            <a:ext cx="12191695" cy="566928"/>
+          </a:xfrm>
+          <a:prstGeom prst="rect">
+            <a:avLst/>
+          </a:prstGeom>
+          <a:solidFill>
+            <a:srgbClr val="0F2A44"/>
+          </a:solidFill>
+          <a:ln>
+            <a:noFill/>
+          </a:ln>
+        </p:spPr>
+        <p:style>
+          <a:lnRef idx="1">
+            <a:schemeClr val="accent1"/>
+          </a:lnRef>
+          <a:fillRef idx="3">
+            <a:schemeClr val="accent1"/>
+          </a:fillRef>
+          <a:effectRef idx="2">
+            <a:schemeClr val="accent1"/>
+          </a:effectRef>
+          <a:fontRef idx="minor">
+            <a:schemeClr val="lt1"/>
+          </a:fontRef>
+        </p:style>
+        <p:txBody>
+          <a:bodyPr rtlCol="0" anchor="ctr" wrap="square"/>
+          <a:lstStyle/>
+          <a:p>
+            <a:pPr algn="l"/>
+            <a:r>
+              <a:rPr sz="1500" b="1">
+                <a:solidFill>
+                  <a:srgbClr val="FFFFFF"/>
+                </a:solidFill>
+                <a:latin typeface="Calibri"/>
+              </a:rPr>
+              <a:t>PATTERN 6 — DISAGREEMENT IS A SENSOR (POC 06)</a:t>
+            </a:r>
+          </a:p>
+        </p:txBody>
+      </p:sp>
+      <p:sp>
+        <p:nvSpPr>
+          <p:cNvPr id="3" name="TextBox 2"/>
           <p:cNvSpPr txBox="1"/>
           <p:nvPr/>
         </p:nvSpPr>
         <p:spPr>
           <a:xfrm>
-            <a:off x="640080" y="6419088"/>
-            <a:ext cx="10972800" cy="320040"/>
+            <a:off x="640080" y="960120"/>
+            <a:ext cx="6675120" cy="5394960"/>
           </a:xfrm>
           <a:prstGeom prst="rect">
             <a:avLst/>
@@ -4758,15 +4673,292 @@
           </a:bodyPr>
           <a:lstStyle/>
           <a:p>
-            <a:pPr>
-              <a:defRPr sz="1100">
-                <a:solidFill>
-                  <a:srgbClr val="555555"/>
-                </a:solidFill>
-              </a:defRPr>
+            <a:pPr algn="l"/>
+            <a:r>
+              <a:rPr sz="1900" b="1">
+                <a:solidFill>
+                  <a:srgbClr val="0F2A44"/>
+                </a:solidFill>
+                <a:latin typeface="Calibri"/>
+              </a:rPr>
+              <a:t>Structured disagreement allocates scarce human review to the closest fights.</a:t>
+            </a:r>
+          </a:p>
+          <a:p>
+            <a:pPr algn="l">
+              <a:spcBef>
+                <a:spcPts val="700"/>
+              </a:spcBef>
             </a:pPr>
             <a:r>
-              <a:t>GAI Observe LLC · POC Learning Lab · github.com/GAI-Engineering/poc-learning-lab</a:t>
+              <a:rPr sz="1450" b="0">
+                <a:solidFill>
+                  <a:srgbClr val="222222"/>
+                </a:solidFill>
+                <a:latin typeface="Calibri"/>
+              </a:rPr>
+              <a:t>•  3 positions debated (runs/verdicts.csv): C1 auto-renewal at +8% — REJECT (strength 5 for / 11 against) · C2 24-hour incident-notice duty — PROCEED (8 / 5) · C3 uncapped liability — REJECT (2 / 14)</a:t>
+            </a:r>
+          </a:p>
+          <a:p>
+            <a:pPr algn="l">
+              <a:spcBef>
+                <a:spcPts val="700"/>
+              </a:spcBef>
+            </a:pPr>
+            <a:r>
+              <a:rPr sz="1450" b="0">
+                <a:solidFill>
+                  <a:srgbClr val="222222"/>
+                </a:solidFill>
+                <a:latin typeface="Calibri"/>
+              </a:rPr>
+              <a:t>•  Closest fight: C2, balance 0.62 — the most balanced argument in the script and the reviewer's first stop</a:t>
+            </a:r>
+          </a:p>
+          <a:p>
+            <a:pPr algn="l">
+              <a:spcBef>
+                <a:spcPts val="700"/>
+              </a:spcBef>
+            </a:pPr>
+            <a:r>
+              <a:rPr sz="1450" b="0">
+                <a:solidFill>
+                  <a:srgbClr val="222222"/>
+                </a:solidFill>
+                <a:latin typeface="Calibri"/>
+              </a:rPr>
+              <a:t>•  The balance map is an illustrative argument-balance prompt for human review: it locates no genuine uncertainty, is not a risk register, and a real position requires independent evidence and counsel review</a:t>
+            </a:r>
+          </a:p>
+          <a:p>
+            <a:pPr algn="l">
+              <a:spcBef>
+                <a:spcPts val="700"/>
+              </a:spcBef>
+            </a:pPr>
+            <a:r>
+              <a:rPr sz="1450" b="0">
+                <a:solidFill>
+                  <a:srgbClr val="222222"/>
+                </a:solidFill>
+                <a:latin typeface="Calibri"/>
+              </a:rPr>
+              <a:t>•  Adding a fourth position produces four verdicts — the counts are computed, not typed (tests/test_perturbation.py)</a:t>
+            </a:r>
+          </a:p>
+        </p:txBody>
+      </p:sp>
+      <p:pic>
+        <p:nvPicPr>
+          <p:cNvPr id="4" name="Picture 3" descr="infographic-06-debate.png"/>
+          <p:cNvPicPr>
+            <a:picLocks noChangeAspect="1"/>
+          </p:cNvPicPr>
+          <p:nvPr/>
+        </p:nvPicPr>
+        <p:blipFill>
+          <a:blip r:embed="rId2"/>
+          <a:stretch>
+            <a:fillRect/>
+          </a:stretch>
+        </p:blipFill>
+        <p:spPr>
+          <a:xfrm>
+            <a:off x="7635240" y="868680"/>
+            <a:ext cx="4315968" cy="5394960"/>
+          </a:xfrm>
+          <a:prstGeom prst="rect">
+            <a:avLst/>
+          </a:prstGeom>
+        </p:spPr>
+      </p:pic>
+    </p:spTree>
+  </p:cSld>
+  <p:clrMapOvr>
+    <a:masterClrMapping/>
+  </p:clrMapOvr>
+</p:sld>
+</file>
+
+<file path=ppt/slides/slide9.xml><?xml version="1.0" encoding="utf-8"?>
+<p:sld xmlns:a="http://schemas.openxmlformats.org/drawingml/2006/main" xmlns:p="http://schemas.openxmlformats.org/presentationml/2006/main" xmlns:r="http://schemas.openxmlformats.org/officeDocument/2006/relationships">
+  <p:cSld>
+    <p:spTree>
+      <p:nvGrpSpPr>
+        <p:cNvPr id="1" name=""/>
+        <p:cNvGrpSpPr/>
+        <p:nvPr/>
+      </p:nvGrpSpPr>
+      <p:grpSpPr/>
+      <p:sp>
+        <p:nvSpPr>
+          <p:cNvPr id="2" name="Rectangle 1"/>
+          <p:cNvSpPr/>
+          <p:nvPr/>
+        </p:nvSpPr>
+        <p:spPr>
+          <a:xfrm>
+            <a:off x="0" y="0"/>
+            <a:ext cx="12191695" cy="566928"/>
+          </a:xfrm>
+          <a:prstGeom prst="rect">
+            <a:avLst/>
+          </a:prstGeom>
+          <a:solidFill>
+            <a:srgbClr val="0F2A44"/>
+          </a:solidFill>
+          <a:ln>
+            <a:noFill/>
+          </a:ln>
+        </p:spPr>
+        <p:style>
+          <a:lnRef idx="1">
+            <a:schemeClr val="accent1"/>
+          </a:lnRef>
+          <a:fillRef idx="3">
+            <a:schemeClr val="accent1"/>
+          </a:fillRef>
+          <a:effectRef idx="2">
+            <a:schemeClr val="accent1"/>
+          </a:effectRef>
+          <a:fontRef idx="minor">
+            <a:schemeClr val="lt1"/>
+          </a:fontRef>
+        </p:style>
+        <p:txBody>
+          <a:bodyPr rtlCol="0" anchor="ctr" wrap="square"/>
+          <a:lstStyle/>
+          <a:p>
+            <a:pPr algn="l"/>
+            <a:r>
+              <a:rPr sz="1500" b="1">
+                <a:solidFill>
+                  <a:srgbClr val="FFFFFF"/>
+                </a:solidFill>
+                <a:latin typeface="Calibri"/>
+              </a:rPr>
+              <a:t>THE PORTFOLIO VIEW — WHERE THE NEXT EFFORT GOES</a:t>
+            </a:r>
+          </a:p>
+        </p:txBody>
+      </p:sp>
+      <p:sp>
+        <p:nvSpPr>
+          <p:cNvPr id="3" name="TextBox 2"/>
+          <p:cNvSpPr txBox="1"/>
+          <p:nvPr/>
+        </p:nvSpPr>
+        <p:spPr>
+          <a:xfrm>
+            <a:off x="640080" y="1005840"/>
+            <a:ext cx="10972800" cy="5394960"/>
+          </a:xfrm>
+          <a:prstGeom prst="rect">
+            <a:avLst/>
+          </a:prstGeom>
+          <a:noFill/>
+        </p:spPr>
+        <p:txBody>
+          <a:bodyPr wrap="none">
+            <a:spAutoFit/>
+          </a:bodyPr>
+          <a:lstStyle/>
+          <a:p>
+            <a:pPr algn="l"/>
+            <a:r>
+              <a:rPr sz="1900" b="1">
+                <a:solidFill>
+                  <a:srgbClr val="0E7C7B"/>
+                </a:solidFill>
+                <a:latin typeface="Calibri"/>
+              </a:rPr>
+              <a:t>Invest first — POC 03 (RODS)</a:t>
+            </a:r>
+          </a:p>
+          <a:p>
+            <a:pPr algn="l"/>
+            <a:r>
+              <a:rPr sz="1500" b="0">
+                <a:solidFill>
+                  <a:srgbClr val="222222"/>
+                </a:solidFill>
+                <a:latin typeface="Calibri"/>
+              </a:rPr>
+              <a:t>The contract pattern is the most transferable asset in the lab: four lines, a linter, a typed completion signal. It generalises to every agent the lab will ever ship.</a:t>
+            </a:r>
+          </a:p>
+          <a:p>
+            <a:pPr algn="l"/>
+            <a:r>
+              <a:rPr sz="1900" b="1">
+                <a:solidFill>
+                  <a:srgbClr val="0E7C7B"/>
+                </a:solidFill>
+                <a:latin typeface="Calibri"/>
+              </a:rPr>
+              <a:t>Gated — POC 02 (transcripts)</a:t>
+            </a:r>
+          </a:p>
+          <a:p>
+            <a:pPr algn="l"/>
+            <a:r>
+              <a:rPr sz="1500" b="0">
+                <a:solidFill>
+                  <a:srgbClr val="222222"/>
+                </a:solidFill>
+                <a:latin typeface="Calibri"/>
+              </a:rPr>
+              <a:t>The system-of-record pattern proceeds behind its durability gates: persistence, replay and failure recovery proven before any stronger claim.</a:t>
+            </a:r>
+          </a:p>
+          <a:p>
+            <a:pPr algn="l"/>
+            <a:r>
+              <a:rPr sz="1900" b="1">
+                <a:solidFill>
+                  <a:srgbClr val="0E7C7B"/>
+                </a:solidFill>
+                <a:latin typeface="Calibri"/>
+              </a:rPr>
+              <a:t>Teaching demo — POC 01 (perception)</a:t>
+            </a:r>
+          </a:p>
+          <a:p>
+            <a:pPr algn="l"/>
+            <a:r>
+              <a:rPr sz="1500" b="0">
+                <a:solidFill>
+                  <a:srgbClr val="222222"/>
+                </a:solidFill>
+                <a:latin typeface="Calibri"/>
+              </a:rPr>
+              <a:t>Held as a teaching artefact until a real perception adapter replaces the scripted scene. Its lesson — the verification loop — is already load-bearing in POC 04.</a:t>
+            </a:r>
+          </a:p>
+          <a:p>
+            <a:pPr algn="l"/>
+            <a:r>
+              <a:rPr sz="1900" b="1">
+                <a:solidFill>
+                  <a:srgbClr val="0E7C7B"/>
+                </a:solidFill>
+                <a:latin typeface="Calibri"/>
+              </a:rPr>
+              <a:t>Day 2 (POCs 04–06)</a:t>
+            </a:r>
+          </a:p>
+          <a:p>
+            <a:pPr algn="l"/>
+            <a:r>
+              <a:rPr sz="1500" b="0">
+                <a:solidFill>
+                  <a:srgbClr val="222222"/>
+                </a:solidFill>
+                <a:latin typeface="Calibri"/>
+              </a:rPr>
+              <a:t>The analyst–executor loop, group-chat routing shapes and structured debate extend the same discipline: labelled outcomes, counted calls, disagreement treated as a sensor.</a:t>
             </a:r>
           </a:p>
         </p:txBody>

</xml_diff>

<commit_message>
Evaluator fixes: all six infographic PNGs re-rendered with one renderer and one serif font set (footers complete); deck rebuilt with word wrap on
</commit_message>
<xml_diff>
--- a/business/POC-BUSINESS-CASE-DECK.pptx
+++ b/business/POC-BUSINESS-CASE-DECK.pptx
@@ -3157,7 +3157,7 @@
           <a:noFill/>
         </p:spPr>
         <p:txBody>
-          <a:bodyPr wrap="none">
+          <a:bodyPr wrap="square">
             <a:spAutoFit/>
           </a:bodyPr>
           <a:lstStyle/>
@@ -3228,7 +3228,7 @@
           <a:noFill/>
         </p:spPr>
         <p:txBody>
-          <a:bodyPr wrap="none">
+          <a:bodyPr wrap="square">
             <a:spAutoFit/>
           </a:bodyPr>
           <a:lstStyle/>
@@ -3333,7 +3333,7 @@
           <a:noFill/>
         </p:spPr>
         <p:txBody>
-          <a:bodyPr wrap="none">
+          <a:bodyPr wrap="square">
             <a:spAutoFit/>
           </a:bodyPr>
           <a:lstStyle/>
@@ -3350,7 +3350,7 @@
                 </a:solidFill>
                 <a:latin typeface="Calibri"/>
               </a:rPr>
-              <a:t>•  Every result is computed from data files in the repo — change an input and the result moves; each notebook carries a perturbation test that proves it.</a:t>
+              <a:t>•  Every result is computed from data files in the repo — change an input and the result moves; the Day 2 notebooks (04–06) carry perturbation tests that prove it, and Day 1’s carry change-one-outcome exercises.</a:t>
             </a:r>
           </a:p>
           <a:p>
@@ -3506,7 +3506,7 @@
           <a:noFill/>
         </p:spPr>
         <p:txBody>
-          <a:bodyPr wrap="none">
+          <a:bodyPr wrap="square">
             <a:spAutoFit/>
           </a:bodyPr>
           <a:lstStyle/>
@@ -3531,7 +3531,7 @@
                 </a:solidFill>
                 <a:latin typeface="Calibri"/>
               </a:rPr>
-              <a:t>Enterprise agentic AI market, 2024 → 2030 (Grand View Research) — 46.2% CAGR. The spend is arriving whether the controls are ready or not.</a:t>
+              <a:t>Enterprise agentic AI market, 2024 → 2030 (Grand View Research), growing at a CAGR of 46.2% from 2025 to 2030. The spend is arriving whether the controls are ready or not.</a:t>
             </a:r>
           </a:p>
           <a:p>
@@ -3579,7 +3579,7 @@
                 </a:solidFill>
                 <a:latin typeface="Calibri"/>
               </a:rPr>
-              <a:t>of agentic AI projects will be cancelled by the end of 2027 (Gartner, June 2025) — cost, unclear value, inadequate risk controls.</a:t>
+              <a:t>of agentic AI projects will be cancelled by the end of 2027 (Gartner, June 2025) — escalating costs, unclear business value or inadequate risk controls.</a:t>
             </a:r>
           </a:p>
           <a:p>
@@ -3603,7 +3603,7 @@
                 </a:solidFill>
                 <a:latin typeface="Calibri"/>
               </a:rPr>
-              <a:t>Contact-center AI spend, 2025 → 2032 (Omdia) — the buyer this lab designs for.</a:t>
+              <a:t>Enterprise agentic AI software market, 2025 → 2030 (Omdia, September 2025) — a second forecaster’s cut of the same surge; forecasts vary by definition and scope.</a:t>
             </a:r>
           </a:p>
           <a:p>
@@ -3628,6 +3628,41 @@
                 <a:latin typeface="Calibri"/>
               </a:rPr>
               <a:t>Growth and cancellation are the same market read twice. The six patterns in this lab are the controls that decide which side of it a deployment lands on.</a:t>
+            </a:r>
+          </a:p>
+        </p:txBody>
+      </p:sp>
+      <p:sp>
+        <p:nvSpPr>
+          <p:cNvPr id="4" name="TextBox 3"/>
+          <p:cNvSpPr txBox="1"/>
+          <p:nvPr/>
+        </p:nvSpPr>
+        <p:spPr>
+          <a:xfrm>
+            <a:off x="640080" y="5989320"/>
+            <a:ext cx="10972800" cy="640080"/>
+          </a:xfrm>
+          <a:prstGeom prst="rect">
+            <a:avLst/>
+          </a:prstGeom>
+          <a:noFill/>
+        </p:spPr>
+        <p:txBody>
+          <a:bodyPr wrap="square">
+            <a:spAutoFit/>
+          </a:bodyPr>
+          <a:lstStyle/>
+          <a:p>
+            <a:pPr algn="l"/>
+            <a:r>
+              <a:rPr sz="1050" b="0">
+                <a:solidFill>
+                  <a:srgbClr val="5A5A5A"/>
+                </a:solidFill>
+                <a:latin typeface="Calibri"/>
+              </a:rPr>
+              <a:t>Sources: grandviewresearch.com/industry-analysis/enterprise-agentic-ai-market-report · gartner.com/en/newsroom/press-releases/2025-08-26-gartner-predicts-40-percent-of-enterprise-apps-will-feature-task-specific-ai-agents-by-2026 · omdia.tech.informa.com/pr/2025/sep/new-omdia-analysis-shows-agentic-ai-outpacing-growth-rates-of-traditional-generative-ai</a:t>
             </a:r>
           </a:p>
         </p:txBody>
@@ -3719,7 +3754,7 @@
           <a:noFill/>
         </p:spPr>
         <p:txBody>
-          <a:bodyPr wrap="none">
+          <a:bodyPr wrap="square">
             <a:spAutoFit/>
           </a:bodyPr>
           <a:lstStyle/>
@@ -3818,7 +3853,7 @@
         <p:spPr>
           <a:xfrm>
             <a:off x="7635240" y="868680"/>
-            <a:ext cx="4316687" cy="5394960"/>
+            <a:ext cx="4315968" cy="5394960"/>
           </a:xfrm>
           <a:prstGeom prst="rect">
             <a:avLst/>
@@ -3912,7 +3947,7 @@
           <a:noFill/>
         </p:spPr>
         <p:txBody>
-          <a:bodyPr wrap="none">
+          <a:bodyPr wrap="square">
             <a:spAutoFit/>
           </a:bodyPr>
           <a:lstStyle/>
@@ -3995,7 +4030,7 @@
         <p:spPr>
           <a:xfrm>
             <a:off x="7635240" y="868680"/>
-            <a:ext cx="4316687" cy="5394960"/>
+            <a:ext cx="4315968" cy="5394960"/>
           </a:xfrm>
           <a:prstGeom prst="rect">
             <a:avLst/>
@@ -4089,7 +4124,7 @@
           <a:noFill/>
         </p:spPr>
         <p:txBody>
-          <a:bodyPr wrap="none">
+          <a:bodyPr wrap="square">
             <a:spAutoFit/>
           </a:bodyPr>
           <a:lstStyle/>
@@ -4172,7 +4207,7 @@
         <p:spPr>
           <a:xfrm>
             <a:off x="7635240" y="868680"/>
-            <a:ext cx="4316687" cy="5394960"/>
+            <a:ext cx="4315968" cy="5394960"/>
           </a:xfrm>
           <a:prstGeom prst="rect">
             <a:avLst/>
@@ -4266,7 +4301,7 @@
           <a:noFill/>
         </p:spPr>
         <p:txBody>
-          <a:bodyPr wrap="none">
+          <a:bodyPr wrap="square">
             <a:spAutoFit/>
           </a:bodyPr>
           <a:lstStyle/>
@@ -4475,7 +4510,7 @@
           <a:noFill/>
         </p:spPr>
         <p:txBody>
-          <a:bodyPr wrap="none">
+          <a:bodyPr wrap="square">
             <a:spAutoFit/>
           </a:bodyPr>
           <a:lstStyle/>
@@ -4668,7 +4703,7 @@
           <a:noFill/>
         </p:spPr>
         <p:txBody>
-          <a:bodyPr wrap="none">
+          <a:bodyPr wrap="square">
             <a:spAutoFit/>
           </a:bodyPr>
           <a:lstStyle/>
@@ -4861,7 +4896,7 @@
           <a:noFill/>
         </p:spPr>
         <p:txBody>
-          <a:bodyPr wrap="none">
+          <a:bodyPr wrap="square">
             <a:spAutoFit/>
           </a:bodyPr>
           <a:lstStyle/>

</xml_diff>

<commit_message>
Branding: emblem medallion on all six cards and the deck title slide
</commit_message>
<xml_diff>
--- a/business/POC-BUSINESS-CASE-DECK.pptx
+++ b/business/POC-BUSINESS-CASE-DECK.pptx
@@ -3246,6 +3246,30 @@
           </a:p>
         </p:txBody>
       </p:sp>
+      <p:pic>
+        <p:nvPicPr>
+          <p:cNvPr id="5" name="Picture 4" descr="gai-observe-emblem-medallion.png"/>
+          <p:cNvPicPr>
+            <a:picLocks noChangeAspect="1"/>
+          </p:cNvPicPr>
+          <p:nvPr/>
+        </p:nvPicPr>
+        <p:blipFill>
+          <a:blip r:embed="rId2"/>
+          <a:stretch>
+            <a:fillRect/>
+          </a:stretch>
+        </p:blipFill>
+        <p:spPr>
+          <a:xfrm>
+            <a:off x="10561320" y="411480"/>
+            <a:ext cx="1188720" cy="1188720"/>
+          </a:xfrm>
+          <a:prstGeom prst="rect">
+            <a:avLst/>
+          </a:prstGeom>
+        </p:spPr>
+      </p:pic>
     </p:spTree>
   </p:cSld>
   <p:clrMapOvr>

</xml_diff>